<commit_message>
docs: sync updated presentation slides for Week 5 and Week 6
</commit_message>
<xml_diff>
--- a/docs/Week5_Uplift_Modeling_Summary.pptx
+++ b/docs/Week5_Uplift_Modeling_Summary.pptx
@@ -3124,16 +3124,13 @@
           </a:bodyPr>
           <a:lstStyle/>
           <a:p>
-            <a:pPr algn="ctr">
-              <a:defRPr sz="4000" b="1">
+            <a:r>
+              <a:rPr>
                 <a:solidFill>
                   <a:srgbClr val="FFFFFF"/>
                 </a:solidFill>
-                <a:latin typeface="Segoe UI"/>
-              </a:defRPr>
-            </a:pPr>
-            <a:r>
-              <a:t>BÁO CÁO TUẦN 7: UPLIFT MODELING</a:t>
+              </a:rPr>
+              <a:t>BÁO CÁO TUẦN 5: UPLIFT MODELING</a:t>
             </a:r>
           </a:p>
         </p:txBody>
@@ -3203,16 +3200,13 @@
           </a:bodyPr>
           <a:lstStyle/>
           <a:p>
-            <a:pPr algn="ctr">
-              <a:defRPr sz="1800">
-                <a:solidFill>
-                  <a:srgbClr val="38BDF8"/>
-                </a:solidFill>
-                <a:latin typeface="Segoe UI"/>
-              </a:defRPr>
-            </a:pPr>
-            <a:r>
-              <a:t>Tối ưu hóa Lợi nhuận bằng Causal AI</a:t>
+            <a:r>
+              <a:rPr>
+                <a:solidFill>
+                  <a:srgbClr val="FFFFFF"/>
+                </a:solidFill>
+              </a:rPr>
+              <a:t>Ước lượng Heterogeneous Treatment Effect và Profit-aware Targeting</a:t>
             </a:r>
           </a:p>
         </p:txBody>
@@ -3317,6 +3311,11 @@
               </a:defRPr>
             </a:pPr>
             <a:r>
+              <a:rPr>
+                <a:solidFill>
+                  <a:srgbClr val="FFFFFF"/>
+                </a:solidFill>
+              </a:rPr>
               <a:t>1. Tại sao cần Uplift Modeling?</a:t>
             </a:r>
           </a:p>
@@ -3353,6 +3352,11 @@
               </a:defRPr>
             </a:pPr>
             <a:r>
+              <a:rPr>
+                <a:solidFill>
+                  <a:srgbClr val="FFFFFF"/>
+                </a:solidFill>
+              </a:rPr>
               <a:t>Giải bài toán Ăn thịt Doanh thu</a:t>
             </a:r>
           </a:p>
@@ -3475,6 +3479,11 @@
               </a:defRPr>
             </a:pPr>
             <a:r>
+              <a:rPr>
+                <a:solidFill>
+                  <a:srgbClr val="FFFFFF"/>
+                </a:solidFill>
+              </a:rPr>
               <a:t>GSM Promotion Experimentation • Báo cáo Chuyên môn • Data Science Team</a:t>
             </a:r>
           </a:p>
@@ -3554,6 +3563,11 @@
               </a:defRPr>
             </a:pPr>
             <a:r>
+              <a:rPr>
+                <a:solidFill>
+                  <a:srgbClr val="FFFFFF"/>
+                </a:solidFill>
+              </a:rPr>
               <a:t>Project: Uplift Modeling &amp; Causal Inference</a:t>
             </a:r>
           </a:p>
@@ -3590,6 +3604,11 @@
               </a:defRPr>
             </a:pPr>
             <a:r>
+              <a:rPr>
+                <a:solidFill>
+                  <a:srgbClr val="FFFFFF"/>
+                </a:solidFill>
+              </a:rPr>
               <a:t>01 / 06</a:t>
             </a:r>
           </a:p>
@@ -3712,6 +3731,11 @@
               </a:defRPr>
             </a:pPr>
             <a:r>
+              <a:rPr>
+                <a:solidFill>
+                  <a:srgbClr val="FFFFFF"/>
+                </a:solidFill>
+              </a:rPr>
               <a:t>Hiệu ứng Cannibalization</a:t>
             </a:r>
           </a:p>
@@ -3739,35 +3763,23 @@
           </a:bodyPr>
           <a:lstStyle/>
           <a:p>
-            <a:pPr>
-              <a:spcAft>
-                <a:spcPts val="600"/>
-              </a:spcAft>
-              <a:defRPr sz="1500">
+            <a:r>
+              <a:rPr>
                 <a:solidFill>
                   <a:srgbClr val="FFFFFF"/>
                 </a:solidFill>
-                <a:latin typeface="Segoe UI"/>
-              </a:defRPr>
-            </a:pPr>
-            <a:r>
-              <a:t>• Khách hàng "Sure Things" đằng nào cũng mua.</a:t>
-            </a:r>
-          </a:p>
-          <a:p>
-            <a:pPr>
-              <a:spcAft>
-                <a:spcPts val="600"/>
-              </a:spcAft>
-              <a:defRPr sz="1500">
+              </a:rPr>
+              <a:t>• Một số user vốn vẫn có nhu cầu đi xe dù không nhận voucher.</a:t>
+            </a:r>
+          </a:p>
+          <a:p>
+            <a:r>
+              <a:rPr>
                 <a:solidFill>
                   <a:srgbClr val="FFFFFF"/>
                 </a:solidFill>
-                <a:latin typeface="Segoe UI"/>
-              </a:defRPr>
-            </a:pPr>
-            <a:r>
-              <a:t>• Phát mã cho nhóm này là ném tiền qua cửa sổ.</a:t>
+              </a:rPr>
+              <a:t>• Phát voucher cho nhóm này có thể tạo promotion waste/cannibalization.</a:t>
             </a:r>
           </a:p>
         </p:txBody>
@@ -3889,6 +3901,11 @@
               </a:defRPr>
             </a:pPr>
             <a:r>
+              <a:rPr>
+                <a:solidFill>
+                  <a:srgbClr val="FFFFFF"/>
+                </a:solidFill>
+              </a:rPr>
               <a:t>Giải pháp Uplift</a:t>
             </a:r>
           </a:p>
@@ -3916,35 +3933,23 @@
           </a:bodyPr>
           <a:lstStyle/>
           <a:p>
-            <a:pPr>
-              <a:spcAft>
-                <a:spcPts val="600"/>
-              </a:spcAft>
-              <a:defRPr sz="1500">
+            <a:r>
+              <a:rPr>
                 <a:solidFill>
                   <a:srgbClr val="FFFFFF"/>
                 </a:solidFill>
-                <a:latin typeface="Segoe UI"/>
-              </a:defRPr>
-            </a:pPr>
-            <a:r>
-              <a:t>• Dự đoán CATE cho TỪNG người.</a:t>
-            </a:r>
-          </a:p>
-          <a:p>
-            <a:pPr>
-              <a:spcAft>
-                <a:spcPts val="600"/>
-              </a:spcAft>
-              <a:defRPr sz="1500">
+              </a:rPr>
+              <a:t>• Ước lượng CATE cho từng user/nhóm user.</a:t>
+            </a:r>
+          </a:p>
+          <a:p>
+            <a:r>
+              <a:rPr>
                 <a:solidFill>
                   <a:srgbClr val="FFFFFF"/>
                 </a:solidFill>
-                <a:latin typeface="Segoe UI"/>
-              </a:defRPr>
-            </a:pPr>
-            <a:r>
-              <a:t>• Tìm ra nhóm "Persuadables" - Chỉ mua khi có mã.</a:t>
+              </a:rPr>
+              <a:t>• Tìm nhóm có incremental response cao hơn khi nhận voucher.</a:t>
             </a:r>
           </a:p>
         </p:txBody>
@@ -4040,16 +4045,13 @@
           </a:bodyPr>
           <a:lstStyle/>
           <a:p>
-            <a:pPr>
-              <a:defRPr sz="2600" b="1">
+            <a:r>
+              <a:rPr>
                 <a:solidFill>
                   <a:srgbClr val="FFFFFF"/>
                 </a:solidFill>
-                <a:latin typeface="Segoe UI"/>
-              </a:defRPr>
-            </a:pPr>
-            <a:r>
-              <a:t>2. Thiết kế &amp; Phân phối CATE</a:t>
+              </a:rPr>
+              <a:t>2. R-Learner &amp; Phân phối CATE</a:t>
             </a:r>
           </a:p>
         </p:txBody>
@@ -4076,16 +4078,13 @@
           </a:bodyPr>
           <a:lstStyle/>
           <a:p>
-            <a:pPr>
-              <a:defRPr sz="1300">
-                <a:solidFill>
-                  <a:srgbClr val="FFB800"/>
-                </a:solidFill>
-                <a:latin typeface="Segoe UI"/>
-              </a:defRPr>
-            </a:pPr>
-            <a:r>
-              <a:t>Sự đa dạng trong tác động của Voucher</a:t>
+            <a:r>
+              <a:rPr>
+                <a:solidFill>
+                  <a:srgbClr val="FFFFFF"/>
+                </a:solidFill>
+              </a:rPr>
+              <a:t>Ước lượng treatment effect dị thể ở cấp user</a:t>
             </a:r>
           </a:p>
         </p:txBody>
@@ -4207,6 +4206,11 @@
               </a:defRPr>
             </a:pPr>
             <a:r>
+              <a:rPr>
+                <a:solidFill>
+                  <a:srgbClr val="FFFFFF"/>
+                </a:solidFill>
+              </a:rPr>
               <a:t>GSM Promotion Experimentation • Báo cáo Chuyên môn • Data Science Team</a:t>
             </a:r>
           </a:p>
@@ -4286,6 +4290,11 @@
               </a:defRPr>
             </a:pPr>
             <a:r>
+              <a:rPr>
+                <a:solidFill>
+                  <a:srgbClr val="FFFFFF"/>
+                </a:solidFill>
+              </a:rPr>
               <a:t>Project: Uplift Modeling &amp; Causal Inference</a:t>
             </a:r>
           </a:p>
@@ -4322,6 +4331,11 @@
               </a:defRPr>
             </a:pPr>
             <a:r>
+              <a:rPr>
+                <a:solidFill>
+                  <a:srgbClr val="FFFFFF"/>
+                </a:solidFill>
+              </a:rPr>
               <a:t>02 / 06</a:t>
             </a:r>
           </a:p>
@@ -4435,16 +4449,13 @@
           </a:bodyPr>
           <a:lstStyle/>
           <a:p>
-            <a:pPr>
-              <a:defRPr sz="1600" b="1">
-                <a:solidFill>
-                  <a:srgbClr val="38BDF8"/>
-                </a:solidFill>
-                <a:latin typeface="Segoe UI"/>
-              </a:defRPr>
-            </a:pPr>
-            <a:r>
-              <a:t>T-Learner (XGBoost)</a:t>
+            <a:r>
+              <a:rPr>
+                <a:solidFill>
+                  <a:srgbClr val="FFFFFF"/>
+                </a:solidFill>
+              </a:rPr>
+              <a:t>R-Learner (XGBoost-based)</a:t>
             </a:r>
           </a:p>
         </p:txBody>
@@ -4471,35 +4482,23 @@
           </a:bodyPr>
           <a:lstStyle/>
           <a:p>
-            <a:pPr>
-              <a:spcAft>
-                <a:spcPts val="400"/>
-              </a:spcAft>
-              <a:defRPr sz="1400">
+            <a:r>
+              <a:rPr>
                 <a:solidFill>
                   <a:srgbClr val="FFFFFF"/>
                 </a:solidFill>
-                <a:latin typeface="Segoe UI"/>
-              </a:defRPr>
-            </a:pPr>
-            <a:r>
-              <a:t>• Áp dụng Two-Model Approach để tìm CATE.</a:t>
-            </a:r>
-          </a:p>
-          <a:p>
-            <a:pPr>
-              <a:spcAft>
-                <a:spcPts val="400"/>
-              </a:spcAft>
-              <a:defRPr sz="1400">
+              </a:rPr>
+              <a:t>• Residualize outcome và treatment để ước lượng HTE.</a:t>
+            </a:r>
+          </a:p>
+          <a:p>
+            <a:r>
+              <a:rPr>
                 <a:solidFill>
                   <a:srgbClr val="FFFFFF"/>
                 </a:solidFill>
-                <a:latin typeface="Segoe UI"/>
-              </a:defRPr>
-            </a:pPr>
-            <a:r>
-              <a:t>• Áp dụng Early Stopping chống Overfitting.</a:t>
+              </a:rPr>
+              <a:t>• Train/Validation/Test = 60/20/20; Test giữ riêng cho final evaluation.</a:t>
             </a:r>
           </a:p>
         </p:txBody>
@@ -4621,6 +4620,11 @@
               </a:defRPr>
             </a:pPr>
             <a:r>
+              <a:rPr>
+                <a:solidFill>
+                  <a:srgbClr val="FFFFFF"/>
+                </a:solidFill>
+              </a:rPr>
               <a:t>Biểu đồ Phân phối</a:t>
             </a:r>
           </a:p>
@@ -4648,19 +4652,13 @@
           </a:bodyPr>
           <a:lstStyle/>
           <a:p>
-            <a:pPr>
-              <a:spcAft>
-                <a:spcPts val="400"/>
-              </a:spcAft>
-              <a:defRPr sz="1400">
+            <a:r>
+              <a:rPr>
                 <a:solidFill>
                   <a:srgbClr val="FFFFFF"/>
                 </a:solidFill>
-                <a:latin typeface="Segoe UI"/>
-              </a:defRPr>
-            </a:pPr>
-            <a:r>
-              <a:t>• Biểu đồ bên phải cho thấy tác động của Voucher có tính phân hóa rất rõ ràng ở từng Users.</a:t>
+              </a:rPr>
+              <a:t>• Phân phối predicted CATE cho thấy response không đồng nhất giữa các user trong synthetic sandbox.</a:t>
             </a:r>
           </a:p>
         </p:txBody>
@@ -4789,6 +4787,11 @@
               </a:defRPr>
             </a:pPr>
             <a:r>
+              <a:rPr>
+                <a:solidFill>
+                  <a:srgbClr val="FFFFFF"/>
+                </a:solidFill>
+              </a:rPr>
               <a:t>3. Đánh giá Mô hình (Qini Curve)</a:t>
             </a:r>
           </a:p>
@@ -4816,16 +4819,13 @@
           </a:bodyPr>
           <a:lstStyle/>
           <a:p>
-            <a:pPr>
-              <a:defRPr sz="1300">
-                <a:solidFill>
-                  <a:srgbClr val="FFB800"/>
-                </a:solidFill>
-                <a:latin typeface="Segoe UI"/>
-              </a:defRPr>
-            </a:pPr>
-            <a:r>
-              <a:t>Mô hình vượt trội so với Random</a:t>
+            <a:r>
+              <a:rPr>
+                <a:solidFill>
+                  <a:srgbClr val="FFFFFF"/>
+                </a:solidFill>
+              </a:rPr>
+              <a:t>Positive ranking signal so với Random</a:t>
             </a:r>
           </a:p>
         </p:txBody>
@@ -4947,6 +4947,11 @@
               </a:defRPr>
             </a:pPr>
             <a:r>
+              <a:rPr>
+                <a:solidFill>
+                  <a:srgbClr val="FFFFFF"/>
+                </a:solidFill>
+              </a:rPr>
               <a:t>GSM Promotion Experimentation • Báo cáo Chuyên môn • Data Science Team</a:t>
             </a:r>
           </a:p>
@@ -5026,6 +5031,11 @@
               </a:defRPr>
             </a:pPr>
             <a:r>
+              <a:rPr>
+                <a:solidFill>
+                  <a:srgbClr val="FFFFFF"/>
+                </a:solidFill>
+              </a:rPr>
               <a:t>Project: Uplift Modeling &amp; Causal Inference</a:t>
             </a:r>
           </a:p>
@@ -5062,6 +5072,11 @@
               </a:defRPr>
             </a:pPr>
             <a:r>
+              <a:rPr>
+                <a:solidFill>
+                  <a:srgbClr val="FFFFFF"/>
+                </a:solidFill>
+              </a:rPr>
               <a:t>03 / 06</a:t>
             </a:r>
           </a:p>
@@ -5184,6 +5199,11 @@
               </a:defRPr>
             </a:pPr>
             <a:r>
+              <a:rPr>
+                <a:solidFill>
+                  <a:srgbClr val="FFFFFF"/>
+                </a:solidFill>
+              </a:rPr>
               <a:t>Đường cong Qini</a:t>
             </a:r>
           </a:p>
@@ -5211,35 +5231,23 @@
           </a:bodyPr>
           <a:lstStyle/>
           <a:p>
-            <a:pPr>
-              <a:spcAft>
-                <a:spcPts val="400"/>
-              </a:spcAft>
-              <a:defRPr sz="1400">
+            <a:r>
+              <a:rPr>
                 <a:solidFill>
                   <a:srgbClr val="FFFFFF"/>
                 </a:solidFill>
-                <a:latin typeface="Segoe UI"/>
-              </a:defRPr>
-            </a:pPr>
-            <a:r>
-              <a:t>• Chỉ số đo lường mức độ gia tăng chuyến đi lũy kế.</a:t>
-            </a:r>
-          </a:p>
-          <a:p>
-            <a:pPr>
-              <a:spcAft>
-                <a:spcPts val="400"/>
-              </a:spcAft>
-              <a:defRPr sz="1400">
+              </a:rPr>
+              <a:t>• Đo khả năng xếp hạng user theo incremental response.</a:t>
+            </a:r>
+          </a:p>
+          <a:p>
+            <a:r>
+              <a:rPr>
                 <a:solidFill>
                   <a:srgbClr val="FFFFFF"/>
                 </a:solidFill>
-                <a:latin typeface="Segoe UI"/>
-              </a:defRPr>
-            </a:pPr>
-            <a:r>
-              <a:t>• Đường màu xanh vồng lên vượt trội so với đường chéo (Random).</a:t>
+              </a:rPr>
+              <a:t>• Đường model nằm trên random baseline cho thấy ranking signal trong synthetic test set.</a:t>
             </a:r>
           </a:p>
         </p:txBody>
@@ -5361,6 +5369,11 @@
               </a:defRPr>
             </a:pPr>
             <a:r>
+              <a:rPr>
+                <a:solidFill>
+                  <a:srgbClr val="FFFFFF"/>
+                </a:solidFill>
+              </a:rPr>
               <a:t>Kết luận Đánh giá</a:t>
             </a:r>
           </a:p>
@@ -5388,19 +5401,23 @@
           </a:bodyPr>
           <a:lstStyle/>
           <a:p>
-            <a:pPr>
-              <a:spcAft>
-                <a:spcPts val="400"/>
-              </a:spcAft>
-              <a:defRPr sz="1400">
+            <a:r>
+              <a:rPr>
                 <a:solidFill>
                   <a:srgbClr val="FFFFFF"/>
                 </a:solidFill>
-                <a:latin typeface="Segoe UI"/>
-              </a:defRPr>
-            </a:pPr>
-            <a:r>
-              <a:t>• Mô hình T-Learner hoàn toàn có khả năng xếp hạng (Ranking) độ nhạy cảm của khách.</a:t>
+              </a:rPr>
+              <a:t>• R-Learner cho thấy positive ranking signal trên held-out synthetic test set.</a:t>
+            </a:r>
+          </a:p>
+          <a:p>
+            <a:r>
+              <a:rPr>
+                <a:solidFill>
+                  <a:srgbClr val="FFFFFF"/>
+                </a:solidFill>
+              </a:rPr>
+              <a:t>• CATE level calibration vẫn imperfect và cần theo dõi.</a:t>
             </a:r>
           </a:p>
         </p:txBody>
@@ -5520,16 +5537,13 @@
           </a:bodyPr>
           <a:lstStyle/>
           <a:p>
-            <a:pPr>
-              <a:defRPr sz="2600" b="1">
+            <a:r>
+              <a:rPr>
                 <a:solidFill>
                   <a:srgbClr val="FFFFFF"/>
                 </a:solidFill>
-                <a:latin typeface="Segoe UI"/>
-              </a:defRPr>
-            </a:pPr>
-            <a:r>
-              <a:t>4. Chuyển hóa Mô hình thành Tiền</a:t>
+              </a:rPr>
+              <a:t>4. Từ Uplift sang Profit-aware Targeting</a:t>
             </a:r>
           </a:p>
         </p:txBody>
@@ -5556,16 +5570,13 @@
           </a:bodyPr>
           <a:lstStyle/>
           <a:p>
-            <a:pPr>
-              <a:defRPr sz="1300">
-                <a:solidFill>
-                  <a:srgbClr val="FFB800"/>
-                </a:solidFill>
-                <a:latin typeface="Segoe UI"/>
-              </a:defRPr>
-            </a:pPr>
-            <a:r>
-              <a:t>Action Distribution</a:t>
+            <a:r>
+              <a:rPr>
+                <a:solidFill>
+                  <a:srgbClr val="FFFFFF"/>
+                </a:solidFill>
+              </a:rPr>
+              <a:t>Decision Layer: Expected Value &gt; 0</a:t>
             </a:r>
           </a:p>
         </p:txBody>
@@ -5687,6 +5698,11 @@
               </a:defRPr>
             </a:pPr>
             <a:r>
+              <a:rPr>
+                <a:solidFill>
+                  <a:srgbClr val="FFFFFF"/>
+                </a:solidFill>
+              </a:rPr>
               <a:t>GSM Promotion Experimentation • Báo cáo Chuyên môn • Data Science Team</a:t>
             </a:r>
           </a:p>
@@ -5766,6 +5782,11 @@
               </a:defRPr>
             </a:pPr>
             <a:r>
+              <a:rPr>
+                <a:solidFill>
+                  <a:srgbClr val="FFFFFF"/>
+                </a:solidFill>
+              </a:rPr>
               <a:t>Project: Uplift Modeling &amp; Causal Inference</a:t>
             </a:r>
           </a:p>
@@ -5802,6 +5823,11 @@
               </a:defRPr>
             </a:pPr>
             <a:r>
+              <a:rPr>
+                <a:solidFill>
+                  <a:srgbClr val="FFFFFF"/>
+                </a:solidFill>
+              </a:rPr>
               <a:t>04 / 06</a:t>
             </a:r>
           </a:p>
@@ -5924,6 +5950,11 @@
               </a:defRPr>
             </a:pPr>
             <a:r>
+              <a:rPr>
+                <a:solidFill>
+                  <a:srgbClr val="FFFFFF"/>
+                </a:solidFill>
+              </a:rPr>
               <a:t>Quyết định phát mã</a:t>
             </a:r>
           </a:p>
@@ -5951,35 +5982,23 @@
           </a:bodyPr>
           <a:lstStyle/>
           <a:p>
-            <a:pPr>
-              <a:spcAft>
-                <a:spcPts val="400"/>
-              </a:spcAft>
-              <a:defRPr sz="1400">
+            <a:r>
+              <a:rPr>
                 <a:solidFill>
                   <a:srgbClr val="FFFFFF"/>
                 </a:solidFill>
-                <a:latin typeface="Segoe UI"/>
-              </a:defRPr>
-            </a:pPr>
-            <a:r>
-              <a:t>• Mô hình cắt lọc và tính toán ra Lợi nhuận kỳ vọng.</a:t>
-            </a:r>
-          </a:p>
-          <a:p>
-            <a:pPr>
-              <a:spcAft>
-                <a:spcPts val="400"/>
-              </a:spcAft>
-              <a:defRPr sz="1400">
+              </a:rPr>
+              <a:t>• Không chỉ tối ưu CATE mà tính cả incremental contribution và expected burn.</a:t>
+            </a:r>
+          </a:p>
+          <a:p>
+            <a:r>
+              <a:rPr>
                 <a:solidFill>
                   <a:srgbClr val="FFFFFF"/>
                 </a:solidFill>
-                <a:latin typeface="Segoe UI"/>
-              </a:defRPr>
-            </a:pPr>
-            <a:r>
-              <a:t>• Chỉ phát Voucher cho nhóm có Expected Profit &gt; 0.</a:t>
+              </a:rPr>
+              <a:t>• Target user khi Expected Incremental Profit &gt; 0.</a:t>
             </a:r>
           </a:p>
         </p:txBody>
@@ -6101,6 +6120,11 @@
               </a:defRPr>
             </a:pPr>
             <a:r>
+              <a:rPr>
+                <a:solidFill>
+                  <a:srgbClr val="FFFFFF"/>
+                </a:solidFill>
+              </a:rPr>
               <a:t>Tỷ lệ Action</a:t>
             </a:r>
           </a:p>
@@ -6128,19 +6152,23 @@
           </a:bodyPr>
           <a:lstStyle/>
           <a:p>
-            <a:pPr>
-              <a:spcAft>
-                <a:spcPts val="400"/>
-              </a:spcAft>
-              <a:defRPr sz="1400">
+            <a:r>
+              <a:rPr>
                 <a:solidFill>
                   <a:srgbClr val="FFFFFF"/>
                 </a:solidFill>
-                <a:latin typeface="Segoe UI"/>
-              </a:defRPr>
-            </a:pPr>
-            <a:r>
-              <a:t>• Biểu đồ cho thấy tỷ lệ cắt giảm đáng kể số lượng Voucher không hiệu quả.</a:t>
+              </a:rPr>
+              <a:t>• Profit Targeting chọn 888/4,000 users (22.2%).</a:t>
+            </a:r>
+          </a:p>
+          <a:p>
+            <a:r>
+              <a:rPr>
+                <a:solidFill>
+                  <a:srgbClr val="FFFFFF"/>
+                </a:solidFill>
+              </a:rPr>
+              <a:t>• Predicted Profit ≈ $7.9k; Synthetic Benchmark ≈ $7.1k.</a:t>
             </a:r>
           </a:p>
         </p:txBody>
@@ -6260,16 +6288,13 @@
           </a:bodyPr>
           <a:lstStyle/>
           <a:p>
-            <a:pPr>
-              <a:defRPr sz="2600" b="1">
+            <a:r>
+              <a:rPr>
                 <a:solidFill>
                   <a:srgbClr val="FFFFFF"/>
                 </a:solidFill>
-                <a:latin typeface="Segoe UI"/>
-              </a:defRPr>
-            </a:pPr>
-            <a:r>
-              <a:t>5. Ngưỡng Hòa Vốn (Break-even)</a:t>
+              </a:rPr>
+              <a:t>5. Profit-aware Decision Rule</a:t>
             </a:r>
           </a:p>
         </p:txBody>
@@ -6296,16 +6321,13 @@
           </a:bodyPr>
           <a:lstStyle/>
           <a:p>
-            <a:pPr>
-              <a:defRPr sz="1300">
-                <a:solidFill>
-                  <a:srgbClr val="FFB800"/>
-                </a:solidFill>
-                <a:latin typeface="Segoe UI"/>
-              </a:defRPr>
-            </a:pPr>
-            <a:r>
-              <a:t>Điểm sinh lời</a:t>
+            <a:r>
+              <a:rPr>
+                <a:solidFill>
+                  <a:srgbClr val="FFFFFF"/>
+                </a:solidFill>
+              </a:rPr>
+              <a:t>High CATE không đồng nghĩa High Profit</a:t>
             </a:r>
           </a:p>
         </p:txBody>
@@ -6427,6 +6449,11 @@
               </a:defRPr>
             </a:pPr>
             <a:r>
+              <a:rPr>
+                <a:solidFill>
+                  <a:srgbClr val="FFFFFF"/>
+                </a:solidFill>
+              </a:rPr>
               <a:t>GSM Promotion Experimentation • Báo cáo Chuyên môn • Data Science Team</a:t>
             </a:r>
           </a:p>
@@ -6506,6 +6533,11 @@
               </a:defRPr>
             </a:pPr>
             <a:r>
+              <a:rPr>
+                <a:solidFill>
+                  <a:srgbClr val="FFFFFF"/>
+                </a:solidFill>
+              </a:rPr>
               <a:t>Project: Uplift Modeling &amp; Causal Inference</a:t>
             </a:r>
           </a:p>
@@ -6542,6 +6574,11 @@
               </a:defRPr>
             </a:pPr>
             <a:r>
+              <a:rPr>
+                <a:solidFill>
+                  <a:srgbClr val="FFFFFF"/>
+                </a:solidFill>
+              </a:rPr>
               <a:t>05 / 06</a:t>
             </a:r>
           </a:p>
@@ -6655,16 +6692,13 @@
           </a:bodyPr>
           <a:lstStyle/>
           <a:p>
-            <a:pPr>
-              <a:defRPr sz="1600" b="1">
-                <a:solidFill>
-                  <a:srgbClr val="FFB800"/>
-                </a:solidFill>
-                <a:latin typeface="Segoe UI"/>
-              </a:defRPr>
-            </a:pPr>
-            <a:r>
-              <a:t>Công thức Hòa Vốn</a:t>
+            <a:r>
+              <a:rPr>
+                <a:solidFill>
+                  <a:srgbClr val="FFFFFF"/>
+                </a:solidFill>
+              </a:rPr>
+              <a:t>Expected Value Rule</a:t>
             </a:r>
           </a:p>
         </p:txBody>
@@ -6691,35 +6725,23 @@
           </a:bodyPr>
           <a:lstStyle/>
           <a:p>
-            <a:pPr>
-              <a:spcAft>
-                <a:spcPts val="600"/>
-              </a:spcAft>
-              <a:defRPr sz="1500">
+            <a:r>
+              <a:rPr>
                 <a:solidFill>
                   <a:srgbClr val="FFFFFF"/>
                 </a:solidFill>
-                <a:latin typeface="Segoe UI"/>
-              </a:defRPr>
-            </a:pPr>
-            <a:r>
-              <a:t>• Chi phí Voucher: 15k, Lãi gộp: 20k.</a:t>
-            </a:r>
-          </a:p>
-          <a:p>
-            <a:pPr>
-              <a:spcAft>
-                <a:spcPts val="600"/>
-              </a:spcAft>
-              <a:defRPr sz="1500">
+              </a:rPr>
+              <a:t>• EV_i = Predicted CATE_i × Margin per Ride_i − Expected Burn_i.</a:t>
+            </a:r>
+          </a:p>
+          <a:p>
+            <a:r>
+              <a:rPr>
                 <a:solidFill>
                   <a:srgbClr val="FFFFFF"/>
                 </a:solidFill>
-                <a:latin typeface="Segoe UI"/>
-              </a:defRPr>
-            </a:pPr>
-            <a:r>
-              <a:t>• Ngưỡng CATE sinh lời = 15k / 20k = 0.75 chuyến.</a:t>
+              </a:rPr>
+              <a:t>• Target khi EV_i &gt; 0 dưới economics assumptions hiện tại.</a:t>
             </a:r>
           </a:p>
         </p:txBody>
@@ -6832,16 +6854,13 @@
           </a:bodyPr>
           <a:lstStyle/>
           <a:p>
-            <a:pPr>
-              <a:defRPr sz="1600" b="1">
-                <a:solidFill>
-                  <a:srgbClr val="F472B6"/>
-                </a:solidFill>
-                <a:latin typeface="Segoe UI"/>
-              </a:defRPr>
-            </a:pPr>
-            <a:r>
-              <a:t>Sự thật tàn nhẫn</a:t>
+            <a:r>
+              <a:rPr>
+                <a:solidFill>
+                  <a:srgbClr val="FFFFFF"/>
+                </a:solidFill>
+              </a:rPr>
+              <a:t>Insight</a:t>
             </a:r>
           </a:p>
         </p:txBody>
@@ -6868,19 +6887,23 @@
           </a:bodyPr>
           <a:lstStyle/>
           <a:p>
-            <a:pPr>
-              <a:spcAft>
-                <a:spcPts val="600"/>
-              </a:spcAft>
-              <a:defRPr sz="1500">
+            <a:r>
+              <a:rPr>
                 <a:solidFill>
                   <a:srgbClr val="FFFFFF"/>
                 </a:solidFill>
-                <a:latin typeface="Segoe UI"/>
-              </a:defRPr>
-            </a:pPr>
-            <a:r>
-              <a:t>• Toàn bộ tập Urban Cash không có ai đạt mức CATE &gt; 0.75.</a:t>
+              </a:rPr>
+              <a:t>• User có uplift cao vẫn có thể không profitable nếu voucher cost lớn.</a:t>
+            </a:r>
+          </a:p>
+          <a:p>
+            <a:r>
+              <a:rPr>
+                <a:solidFill>
+                  <a:srgbClr val="FFFFFF"/>
+                </a:solidFill>
+              </a:rPr>
+              <a:t>• Policy layer cần tối ưu economics, không chỉ response.</a:t>
             </a:r>
           </a:p>
         </p:txBody>
@@ -6976,16 +6999,13 @@
           </a:bodyPr>
           <a:lstStyle/>
           <a:p>
-            <a:pPr>
-              <a:defRPr sz="2600" b="1">
+            <a:r>
+              <a:rPr>
                 <a:solidFill>
                   <a:srgbClr val="FFFFFF"/>
                 </a:solidFill>
-                <a:latin typeface="Segoe UI"/>
-              </a:defRPr>
-            </a:pPr>
-            <a:r>
-              <a:t>6. Đề xuất Hành động (Decision)</a:t>
+              </a:rPr>
+              <a:t>6. Đề xuất Tiếp theo</a:t>
             </a:r>
           </a:p>
         </p:txBody>
@@ -7012,16 +7032,13 @@
           </a:bodyPr>
           <a:lstStyle/>
           <a:p>
-            <a:pPr>
-              <a:defRPr sz="1300">
-                <a:solidFill>
-                  <a:srgbClr val="FFB800"/>
-                </a:solidFill>
-                <a:latin typeface="Segoe UI"/>
-              </a:defRPr>
-            </a:pPr>
-            <a:r>
-              <a:t>Hướng đi tiếp theo</a:t>
+            <a:r>
+              <a:rPr>
+                <a:solidFill>
+                  <a:srgbClr val="FFFFFF"/>
+                </a:solidFill>
+              </a:rPr>
+              <a:t>Simulation Evidence → Real-world Validation</a:t>
             </a:r>
           </a:p>
         </p:txBody>
@@ -7143,6 +7160,11 @@
               </a:defRPr>
             </a:pPr>
             <a:r>
+              <a:rPr>
+                <a:solidFill>
+                  <a:srgbClr val="FFFFFF"/>
+                </a:solidFill>
+              </a:rPr>
               <a:t>GSM Promotion Experimentation • Báo cáo Chuyên môn • Data Science Team</a:t>
             </a:r>
           </a:p>
@@ -7222,6 +7244,11 @@
               </a:defRPr>
             </a:pPr>
             <a:r>
+              <a:rPr>
+                <a:solidFill>
+                  <a:srgbClr val="FFFFFF"/>
+                </a:solidFill>
+              </a:rPr>
               <a:t>Project: Uplift Modeling &amp; Causal Inference</a:t>
             </a:r>
           </a:p>
@@ -7258,6 +7285,11 @@
               </a:defRPr>
             </a:pPr>
             <a:r>
+              <a:rPr>
+                <a:solidFill>
+                  <a:srgbClr val="FFFFFF"/>
+                </a:solidFill>
+              </a:rPr>
               <a:t>06 / 06</a:t>
             </a:r>
           </a:p>
@@ -7371,16 +7403,13 @@
           </a:bodyPr>
           <a:lstStyle/>
           <a:p>
-            <a:pPr>
-              <a:defRPr sz="1600" b="1">
-                <a:solidFill>
-                  <a:srgbClr val="FFB800"/>
-                </a:solidFill>
-                <a:latin typeface="Segoe UI"/>
-              </a:defRPr>
-            </a:pPr>
-            <a:r>
-              <a:t>1. DỪNG CHIẾN DỊCH URBAN</a:t>
+            <a:r>
+              <a:rPr>
+                <a:solidFill>
+                  <a:srgbClr val="FFFFFF"/>
+                </a:solidFill>
+              </a:rPr>
+              <a:t>1. Profit-based Targeting</a:t>
             </a:r>
           </a:p>
         </p:txBody>
@@ -7407,19 +7436,13 @@
           </a:bodyPr>
           <a:lstStyle/>
           <a:p>
-            <a:pPr>
-              <a:spcAft>
-                <a:spcPts val="600"/>
-              </a:spcAft>
-              <a:defRPr sz="1500">
+            <a:r>
+              <a:rPr>
                 <a:solidFill>
                   <a:srgbClr val="FFFFFF"/>
                 </a:solidFill>
-                <a:latin typeface="Segoe UI"/>
-              </a:defRPr>
-            </a:pPr>
-            <a:r>
-              <a:t>• Dừng phát mã cho nhóm Urban Cash để bảo toàn vốn.</a:t>
+              </a:rPr>
+              <a:t>• Trong synthetic sandbox, ưu tiên users có Expected Incremental Profit &gt; 0.</a:t>
             </a:r>
           </a:p>
         </p:txBody>
@@ -7532,16 +7555,13 @@
           </a:bodyPr>
           <a:lstStyle/>
           <a:p>
-            <a:pPr>
-              <a:defRPr sz="1600" b="1">
-                <a:solidFill>
-                  <a:srgbClr val="38BDF8"/>
-                </a:solidFill>
-                <a:latin typeface="Segoe UI"/>
-              </a:defRPr>
-            </a:pPr>
-            <a:r>
-              <a:t>2. GATEKEEPER</a:t>
+            <a:r>
+              <a:rPr>
+                <a:solidFill>
+                  <a:srgbClr val="FFFFFF"/>
+                </a:solidFill>
+              </a:rPr>
+              <a:t>2. R-Learner Ranking</a:t>
             </a:r>
           </a:p>
         </p:txBody>
@@ -7568,19 +7588,13 @@
           </a:bodyPr>
           <a:lstStyle/>
           <a:p>
-            <a:pPr>
-              <a:spcAft>
-                <a:spcPts val="600"/>
-              </a:spcAft>
-              <a:defRPr sz="1500">
+            <a:r>
+              <a:rPr>
                 <a:solidFill>
                   <a:srgbClr val="FFFFFF"/>
                 </a:solidFill>
-                <a:latin typeface="Segoe UI"/>
-              </a:defRPr>
-            </a:pPr>
-            <a:r>
-              <a:t>• Dùng T-Learner làm màng lọc CATE &gt; 0.75 cho mọi campaign tương lai.</a:t>
+              </a:rPr>
+              <a:t>• Dùng heterogeneous response để hỗ trợ targeting, không chỉ dựa vào behavioral segmentation.</a:t>
             </a:r>
           </a:p>
         </p:txBody>
@@ -7693,16 +7707,13 @@
           </a:bodyPr>
           <a:lstStyle/>
           <a:p>
-            <a:pPr>
-              <a:defRPr sz="1600" b="1">
-                <a:solidFill>
-                  <a:srgbClr val="34D399"/>
-                </a:solidFill>
-                <a:latin typeface="Segoe UI"/>
-              </a:defRPr>
-            </a:pPr>
-            <a:r>
-              <a:t>3. DỊCH CHUYỂN NGÂN SÁCH</a:t>
+            <a:r>
+              <a:rPr>
+                <a:solidFill>
+                  <a:srgbClr val="FFFFFF"/>
+                </a:solidFill>
+              </a:rPr>
+              <a:t>3. Validation tiếp theo</a:t>
             </a:r>
           </a:p>
         </p:txBody>
@@ -7729,19 +7740,13 @@
           </a:bodyPr>
           <a:lstStyle/>
           <a:p>
-            <a:pPr>
-              <a:spcAft>
-                <a:spcPts val="600"/>
-              </a:spcAft>
-              <a:defRPr sz="1500">
+            <a:r>
+              <a:rPr>
                 <a:solidFill>
                   <a:srgbClr val="FFFFFF"/>
                 </a:solidFill>
-                <a:latin typeface="Segoe UI"/>
-              </a:defRPr>
-            </a:pPr>
-            <a:r>
-              <a:t>• Tái phân bổ ngân sách sang nhóm Suburban tiềm năng hơn.</a:t>
+              </a:rPr>
+              <a:t>• Kết quả hiện là simulation evidence; real policy cần randomized experiment trên data GSM thật.</a:t>
             </a:r>
           </a:p>
         </p:txBody>

</xml_diff>

<commit_message>
Refresh Week 5 and Week 6 mentor reports
</commit_message>
<xml_diff>
--- a/docs/Week5_Uplift_Modeling_Summary.pptx
+++ b/docs/Week5_Uplift_Modeling_Summary.pptx
@@ -5,13 +5,13 @@
     <p:sldMasterId id="2147483648" r:id="rId1"/>
   </p:sldMasterIdLst>
   <p:sldIdLst>
-    <p:sldId id="256" r:id="rId7"/>
-    <p:sldId id="257" r:id="rId8"/>
-    <p:sldId id="258" r:id="rId9"/>
-    <p:sldId id="259" r:id="rId10"/>
-    <p:sldId id="260" r:id="rId11"/>
-    <p:sldId id="261" r:id="rId12"/>
-    <p:sldId id="262" r:id="rId13"/>
+    <p:sldId id="256" r:id="rId2"/>
+    <p:sldId id="257" r:id="rId3"/>
+    <p:sldId id="258" r:id="rId4"/>
+    <p:sldId id="259" r:id="rId5"/>
+    <p:sldId id="260" r:id="rId6"/>
+    <p:sldId id="261" r:id="rId7"/>
+    <p:sldId id="262" r:id="rId8"/>
   </p:sldIdLst>
   <p:sldSz cx="9144000" cy="6858000" type="screen4x3"/>
   <p:notesSz cx="6858000" cy="9144000"/>
@@ -110,6 +110,22 @@
       </a:defRPr>
     </a:lvl9pPr>
   </p:defaultTextStyle>
+  <p:extLst>
+    <p:ext uri="{EFAFB233-063F-42B5-8137-9DF3F51BA10A}">
+      <p15:sldGuideLst xmlns:p15="http://schemas.microsoft.com/office/powerpoint/2012/main">
+        <p15:guide id="1" orient="horz" pos="2160">
+          <p15:clr>
+            <a:srgbClr val="A4A3A4"/>
+          </p15:clr>
+        </p15:guide>
+        <p15:guide id="2" pos="2880">
+          <p15:clr>
+            <a:srgbClr val="A4A3A4"/>
+          </p15:clr>
+        </p15:guide>
+      </p15:sldGuideLst>
+    </p:ext>
+  </p:extLst>
 </p:presentation>
 </file>
 
@@ -151,10 +167,9 @@
           <a:lstStyle/>
           <a:p>
             <a:r>
-              <a:rPr lang="en-US" smtClean="0"/>
+              <a:rPr lang="en-US"/>
               <a:t>Click to edit Master title style</a:t>
             </a:r>
-            <a:endParaRPr lang="en-US"/>
           </a:p>
         </p:txBody>
       </p:sp>
@@ -270,10 +285,9 @@
           </a:lstStyle>
           <a:p>
             <a:r>
-              <a:rPr lang="en-US" smtClean="0"/>
+              <a:rPr lang="en-US"/>
               <a:t>Click to edit Master subtitle style</a:t>
             </a:r>
-            <a:endParaRPr lang="en-US"/>
           </a:p>
         </p:txBody>
       </p:sp>
@@ -294,7 +308,7 @@
           <a:p>
             <a:fld id="{5BCAD085-E8A6-8845-BD4E-CB4CCA059FC4}" type="datetimeFigureOut">
               <a:rPr lang="en-US" smtClean="0"/>
-              <a:t>1/27/13</a:t>
+              <a:t>8/20/2026</a:t>
             </a:fld>
             <a:endParaRPr lang="en-US"/>
           </a:p>
@@ -388,10 +402,9 @@
           <a:lstStyle/>
           <a:p>
             <a:r>
-              <a:rPr lang="en-US" smtClean="0"/>
+              <a:rPr lang="en-US"/>
               <a:t>Click to edit Master title style</a:t>
             </a:r>
-            <a:endParaRPr lang="en-US"/>
           </a:p>
         </p:txBody>
       </p:sp>
@@ -412,38 +425,37 @@
           <a:p>
             <a:pPr lvl="0"/>
             <a:r>
-              <a:rPr lang="en-US" smtClean="0"/>
+              <a:rPr lang="en-US"/>
               <a:t>Click to edit Master text styles</a:t>
             </a:r>
           </a:p>
           <a:p>
             <a:pPr lvl="1"/>
             <a:r>
-              <a:rPr lang="en-US" smtClean="0"/>
+              <a:rPr lang="en-US"/>
               <a:t>Second level</a:t>
             </a:r>
           </a:p>
           <a:p>
             <a:pPr lvl="2"/>
             <a:r>
-              <a:rPr lang="en-US" smtClean="0"/>
+              <a:rPr lang="en-US"/>
               <a:t>Third level</a:t>
             </a:r>
           </a:p>
           <a:p>
             <a:pPr lvl="3"/>
             <a:r>
-              <a:rPr lang="en-US" smtClean="0"/>
+              <a:rPr lang="en-US"/>
               <a:t>Fourth level</a:t>
             </a:r>
           </a:p>
           <a:p>
             <a:pPr lvl="4"/>
             <a:r>
-              <a:rPr lang="en-US" smtClean="0"/>
+              <a:rPr lang="en-US"/>
               <a:t>Fifth level</a:t>
             </a:r>
-            <a:endParaRPr lang="en-US"/>
           </a:p>
         </p:txBody>
       </p:sp>
@@ -464,7 +476,7 @@
           <a:p>
             <a:fld id="{5BCAD085-E8A6-8845-BD4E-CB4CCA059FC4}" type="datetimeFigureOut">
               <a:rPr lang="en-US" smtClean="0"/>
-              <a:t>1/27/13</a:t>
+              <a:t>8/20/2026</a:t>
             </a:fld>
             <a:endParaRPr lang="en-US"/>
           </a:p>
@@ -563,10 +575,9 @@
           <a:lstStyle/>
           <a:p>
             <a:r>
-              <a:rPr lang="en-US" smtClean="0"/>
+              <a:rPr lang="en-US"/>
               <a:t>Click to edit Master title style</a:t>
             </a:r>
-            <a:endParaRPr lang="en-US"/>
           </a:p>
         </p:txBody>
       </p:sp>
@@ -592,38 +603,37 @@
           <a:p>
             <a:pPr lvl="0"/>
             <a:r>
-              <a:rPr lang="en-US" smtClean="0"/>
+              <a:rPr lang="en-US"/>
               <a:t>Click to edit Master text styles</a:t>
             </a:r>
           </a:p>
           <a:p>
             <a:pPr lvl="1"/>
             <a:r>
-              <a:rPr lang="en-US" smtClean="0"/>
+              <a:rPr lang="en-US"/>
               <a:t>Second level</a:t>
             </a:r>
           </a:p>
           <a:p>
             <a:pPr lvl="2"/>
             <a:r>
-              <a:rPr lang="en-US" smtClean="0"/>
+              <a:rPr lang="en-US"/>
               <a:t>Third level</a:t>
             </a:r>
           </a:p>
           <a:p>
             <a:pPr lvl="3"/>
             <a:r>
-              <a:rPr lang="en-US" smtClean="0"/>
+              <a:rPr lang="en-US"/>
               <a:t>Fourth level</a:t>
             </a:r>
           </a:p>
           <a:p>
             <a:pPr lvl="4"/>
             <a:r>
-              <a:rPr lang="en-US" smtClean="0"/>
+              <a:rPr lang="en-US"/>
               <a:t>Fifth level</a:t>
             </a:r>
-            <a:endParaRPr lang="en-US"/>
           </a:p>
         </p:txBody>
       </p:sp>
@@ -644,7 +654,7 @@
           <a:p>
             <a:fld id="{5BCAD085-E8A6-8845-BD4E-CB4CCA059FC4}" type="datetimeFigureOut">
               <a:rPr lang="en-US" smtClean="0"/>
-              <a:t>1/27/13</a:t>
+              <a:t>8/20/2026</a:t>
             </a:fld>
             <a:endParaRPr lang="en-US"/>
           </a:p>
@@ -738,10 +748,9 @@
           <a:lstStyle/>
           <a:p>
             <a:r>
-              <a:rPr lang="en-US" smtClean="0"/>
+              <a:rPr lang="en-US"/>
               <a:t>Click to edit Master title style</a:t>
             </a:r>
-            <a:endParaRPr lang="en-US"/>
           </a:p>
         </p:txBody>
       </p:sp>
@@ -762,38 +771,37 @@
           <a:p>
             <a:pPr lvl="0"/>
             <a:r>
-              <a:rPr lang="en-US" smtClean="0"/>
+              <a:rPr lang="en-US"/>
               <a:t>Click to edit Master text styles</a:t>
             </a:r>
           </a:p>
           <a:p>
             <a:pPr lvl="1"/>
             <a:r>
-              <a:rPr lang="en-US" smtClean="0"/>
+              <a:rPr lang="en-US"/>
               <a:t>Second level</a:t>
             </a:r>
           </a:p>
           <a:p>
             <a:pPr lvl="2"/>
             <a:r>
-              <a:rPr lang="en-US" smtClean="0"/>
+              <a:rPr lang="en-US"/>
               <a:t>Third level</a:t>
             </a:r>
           </a:p>
           <a:p>
             <a:pPr lvl="3"/>
             <a:r>
-              <a:rPr lang="en-US" smtClean="0"/>
+              <a:rPr lang="en-US"/>
               <a:t>Fourth level</a:t>
             </a:r>
           </a:p>
           <a:p>
             <a:pPr lvl="4"/>
             <a:r>
-              <a:rPr lang="en-US" smtClean="0"/>
+              <a:rPr lang="en-US"/>
               <a:t>Fifth level</a:t>
             </a:r>
-            <a:endParaRPr lang="en-US"/>
           </a:p>
         </p:txBody>
       </p:sp>
@@ -814,7 +822,7 @@
           <a:p>
             <a:fld id="{5BCAD085-E8A6-8845-BD4E-CB4CCA059FC4}" type="datetimeFigureOut">
               <a:rPr lang="en-US" smtClean="0"/>
-              <a:t>1/27/13</a:t>
+              <a:t>8/20/2026</a:t>
             </a:fld>
             <a:endParaRPr lang="en-US"/>
           </a:p>
@@ -917,10 +925,9 @@
           </a:lstStyle>
           <a:p>
             <a:r>
-              <a:rPr lang="en-US" smtClean="0"/>
+              <a:rPr lang="en-US"/>
               <a:t>Click to edit Master title style</a:t>
             </a:r>
-            <a:endParaRPr lang="en-US"/>
           </a:p>
         </p:txBody>
       </p:sp>
@@ -1037,7 +1044,7 @@
           <a:p>
             <a:pPr lvl="0"/>
             <a:r>
-              <a:rPr lang="en-US" smtClean="0"/>
+              <a:rPr lang="en-US"/>
               <a:t>Click to edit Master text styles</a:t>
             </a:r>
           </a:p>
@@ -1060,7 +1067,7 @@
           <a:p>
             <a:fld id="{5BCAD085-E8A6-8845-BD4E-CB4CCA059FC4}" type="datetimeFigureOut">
               <a:rPr lang="en-US" smtClean="0"/>
-              <a:t>1/27/13</a:t>
+              <a:t>8/20/2026</a:t>
             </a:fld>
             <a:endParaRPr lang="en-US"/>
           </a:p>
@@ -1154,10 +1161,9 @@
           <a:lstStyle/>
           <a:p>
             <a:r>
-              <a:rPr lang="en-US" smtClean="0"/>
+              <a:rPr lang="en-US"/>
               <a:t>Click to edit Master title style</a:t>
             </a:r>
-            <a:endParaRPr lang="en-US"/>
           </a:p>
         </p:txBody>
       </p:sp>
@@ -1211,38 +1217,37 @@
           <a:p>
             <a:pPr lvl="0"/>
             <a:r>
-              <a:rPr lang="en-US" smtClean="0"/>
+              <a:rPr lang="en-US"/>
               <a:t>Click to edit Master text styles</a:t>
             </a:r>
           </a:p>
           <a:p>
             <a:pPr lvl="1"/>
             <a:r>
-              <a:rPr lang="en-US" smtClean="0"/>
+              <a:rPr lang="en-US"/>
               <a:t>Second level</a:t>
             </a:r>
           </a:p>
           <a:p>
             <a:pPr lvl="2"/>
             <a:r>
-              <a:rPr lang="en-US" smtClean="0"/>
+              <a:rPr lang="en-US"/>
               <a:t>Third level</a:t>
             </a:r>
           </a:p>
           <a:p>
             <a:pPr lvl="3"/>
             <a:r>
-              <a:rPr lang="en-US" smtClean="0"/>
+              <a:rPr lang="en-US"/>
               <a:t>Fourth level</a:t>
             </a:r>
           </a:p>
           <a:p>
             <a:pPr lvl="4"/>
             <a:r>
-              <a:rPr lang="en-US" smtClean="0"/>
+              <a:rPr lang="en-US"/>
               <a:t>Fifth level</a:t>
             </a:r>
-            <a:endParaRPr lang="en-US"/>
           </a:p>
         </p:txBody>
       </p:sp>
@@ -1296,38 +1301,37 @@
           <a:p>
             <a:pPr lvl="0"/>
             <a:r>
-              <a:rPr lang="en-US" smtClean="0"/>
+              <a:rPr lang="en-US"/>
               <a:t>Click to edit Master text styles</a:t>
             </a:r>
           </a:p>
           <a:p>
             <a:pPr lvl="1"/>
             <a:r>
-              <a:rPr lang="en-US" smtClean="0"/>
+              <a:rPr lang="en-US"/>
               <a:t>Second level</a:t>
             </a:r>
           </a:p>
           <a:p>
             <a:pPr lvl="2"/>
             <a:r>
-              <a:rPr lang="en-US" smtClean="0"/>
+              <a:rPr lang="en-US"/>
               <a:t>Third level</a:t>
             </a:r>
           </a:p>
           <a:p>
             <a:pPr lvl="3"/>
             <a:r>
-              <a:rPr lang="en-US" smtClean="0"/>
+              <a:rPr lang="en-US"/>
               <a:t>Fourth level</a:t>
             </a:r>
           </a:p>
           <a:p>
             <a:pPr lvl="4"/>
             <a:r>
-              <a:rPr lang="en-US" smtClean="0"/>
+              <a:rPr lang="en-US"/>
               <a:t>Fifth level</a:t>
             </a:r>
-            <a:endParaRPr lang="en-US"/>
           </a:p>
         </p:txBody>
       </p:sp>
@@ -1348,7 +1352,7 @@
           <a:p>
             <a:fld id="{5BCAD085-E8A6-8845-BD4E-CB4CCA059FC4}" type="datetimeFigureOut">
               <a:rPr lang="en-US" smtClean="0"/>
-              <a:t>1/27/13</a:t>
+              <a:t>8/20/2026</a:t>
             </a:fld>
             <a:endParaRPr lang="en-US"/>
           </a:p>
@@ -1446,10 +1450,9 @@
           </a:lstStyle>
           <a:p>
             <a:r>
-              <a:rPr lang="en-US" smtClean="0"/>
+              <a:rPr lang="en-US"/>
               <a:t>Click to edit Master title style</a:t>
             </a:r>
-            <a:endParaRPr lang="en-US"/>
           </a:p>
         </p:txBody>
       </p:sp>
@@ -1512,7 +1515,7 @@
           <a:p>
             <a:pPr lvl="0"/>
             <a:r>
-              <a:rPr lang="en-US" smtClean="0"/>
+              <a:rPr lang="en-US"/>
               <a:t>Click to edit Master text styles</a:t>
             </a:r>
           </a:p>
@@ -1568,38 +1571,37 @@
           <a:p>
             <a:pPr lvl="0"/>
             <a:r>
-              <a:rPr lang="en-US" smtClean="0"/>
+              <a:rPr lang="en-US"/>
               <a:t>Click to edit Master text styles</a:t>
             </a:r>
           </a:p>
           <a:p>
             <a:pPr lvl="1"/>
             <a:r>
-              <a:rPr lang="en-US" smtClean="0"/>
+              <a:rPr lang="en-US"/>
               <a:t>Second level</a:t>
             </a:r>
           </a:p>
           <a:p>
             <a:pPr lvl="2"/>
             <a:r>
-              <a:rPr lang="en-US" smtClean="0"/>
+              <a:rPr lang="en-US"/>
               <a:t>Third level</a:t>
             </a:r>
           </a:p>
           <a:p>
             <a:pPr lvl="3"/>
             <a:r>
-              <a:rPr lang="en-US" smtClean="0"/>
+              <a:rPr lang="en-US"/>
               <a:t>Fourth level</a:t>
             </a:r>
           </a:p>
           <a:p>
             <a:pPr lvl="4"/>
             <a:r>
-              <a:rPr lang="en-US" smtClean="0"/>
+              <a:rPr lang="en-US"/>
               <a:t>Fifth level</a:t>
             </a:r>
-            <a:endParaRPr lang="en-US"/>
           </a:p>
         </p:txBody>
       </p:sp>
@@ -1662,7 +1664,7 @@
           <a:p>
             <a:pPr lvl="0"/>
             <a:r>
-              <a:rPr lang="en-US" smtClean="0"/>
+              <a:rPr lang="en-US"/>
               <a:t>Click to edit Master text styles</a:t>
             </a:r>
           </a:p>
@@ -1718,38 +1720,37 @@
           <a:p>
             <a:pPr lvl="0"/>
             <a:r>
-              <a:rPr lang="en-US" smtClean="0"/>
+              <a:rPr lang="en-US"/>
               <a:t>Click to edit Master text styles</a:t>
             </a:r>
           </a:p>
           <a:p>
             <a:pPr lvl="1"/>
             <a:r>
-              <a:rPr lang="en-US" smtClean="0"/>
+              <a:rPr lang="en-US"/>
               <a:t>Second level</a:t>
             </a:r>
           </a:p>
           <a:p>
             <a:pPr lvl="2"/>
             <a:r>
-              <a:rPr lang="en-US" smtClean="0"/>
+              <a:rPr lang="en-US"/>
               <a:t>Third level</a:t>
             </a:r>
           </a:p>
           <a:p>
             <a:pPr lvl="3"/>
             <a:r>
-              <a:rPr lang="en-US" smtClean="0"/>
+              <a:rPr lang="en-US"/>
               <a:t>Fourth level</a:t>
             </a:r>
           </a:p>
           <a:p>
             <a:pPr lvl="4"/>
             <a:r>
-              <a:rPr lang="en-US" smtClean="0"/>
+              <a:rPr lang="en-US"/>
               <a:t>Fifth level</a:t>
             </a:r>
-            <a:endParaRPr lang="en-US"/>
           </a:p>
         </p:txBody>
       </p:sp>
@@ -1770,7 +1771,7 @@
           <a:p>
             <a:fld id="{5BCAD085-E8A6-8845-BD4E-CB4CCA059FC4}" type="datetimeFigureOut">
               <a:rPr lang="en-US" smtClean="0"/>
-              <a:t>1/27/13</a:t>
+              <a:t>8/20/2026</a:t>
             </a:fld>
             <a:endParaRPr lang="en-US"/>
           </a:p>
@@ -1864,10 +1865,9 @@
           <a:lstStyle/>
           <a:p>
             <a:r>
-              <a:rPr lang="en-US" smtClean="0"/>
+              <a:rPr lang="en-US"/>
               <a:t>Click to edit Master title style</a:t>
             </a:r>
-            <a:endParaRPr lang="en-US"/>
           </a:p>
         </p:txBody>
       </p:sp>
@@ -1888,7 +1888,7 @@
           <a:p>
             <a:fld id="{5BCAD085-E8A6-8845-BD4E-CB4CCA059FC4}" type="datetimeFigureOut">
               <a:rPr lang="en-US" smtClean="0"/>
-              <a:t>1/27/13</a:t>
+              <a:t>8/20/2026</a:t>
             </a:fld>
             <a:endParaRPr lang="en-US"/>
           </a:p>
@@ -1983,7 +1983,7 @@
           <a:p>
             <a:fld id="{5BCAD085-E8A6-8845-BD4E-CB4CCA059FC4}" type="datetimeFigureOut">
               <a:rPr lang="en-US" smtClean="0"/>
-              <a:t>1/27/13</a:t>
+              <a:t>8/20/2026</a:t>
             </a:fld>
             <a:endParaRPr lang="en-US"/>
           </a:p>
@@ -2086,10 +2086,9 @@
           </a:lstStyle>
           <a:p>
             <a:r>
-              <a:rPr lang="en-US" smtClean="0"/>
+              <a:rPr lang="en-US"/>
               <a:t>Click to edit Master title style</a:t>
             </a:r>
-            <a:endParaRPr lang="en-US"/>
           </a:p>
         </p:txBody>
       </p:sp>
@@ -2143,38 +2142,37 @@
           <a:p>
             <a:pPr lvl="0"/>
             <a:r>
-              <a:rPr lang="en-US" smtClean="0"/>
+              <a:rPr lang="en-US"/>
               <a:t>Click to edit Master text styles</a:t>
             </a:r>
           </a:p>
           <a:p>
             <a:pPr lvl="1"/>
             <a:r>
-              <a:rPr lang="en-US" smtClean="0"/>
+              <a:rPr lang="en-US"/>
               <a:t>Second level</a:t>
             </a:r>
           </a:p>
           <a:p>
             <a:pPr lvl="2"/>
             <a:r>
-              <a:rPr lang="en-US" smtClean="0"/>
+              <a:rPr lang="en-US"/>
               <a:t>Third level</a:t>
             </a:r>
           </a:p>
           <a:p>
             <a:pPr lvl="3"/>
             <a:r>
-              <a:rPr lang="en-US" smtClean="0"/>
+              <a:rPr lang="en-US"/>
               <a:t>Fourth level</a:t>
             </a:r>
           </a:p>
           <a:p>
             <a:pPr lvl="4"/>
             <a:r>
-              <a:rPr lang="en-US" smtClean="0"/>
+              <a:rPr lang="en-US"/>
               <a:t>Fifth level</a:t>
             </a:r>
-            <a:endParaRPr lang="en-US"/>
           </a:p>
         </p:txBody>
       </p:sp>
@@ -2237,7 +2235,7 @@
           <a:p>
             <a:pPr lvl="0"/>
             <a:r>
-              <a:rPr lang="en-US" smtClean="0"/>
+              <a:rPr lang="en-US"/>
               <a:t>Click to edit Master text styles</a:t>
             </a:r>
           </a:p>
@@ -2260,7 +2258,7 @@
           <a:p>
             <a:fld id="{5BCAD085-E8A6-8845-BD4E-CB4CCA059FC4}" type="datetimeFigureOut">
               <a:rPr lang="en-US" smtClean="0"/>
-              <a:t>1/27/13</a:t>
+              <a:t>8/20/2026</a:t>
             </a:fld>
             <a:endParaRPr lang="en-US"/>
           </a:p>
@@ -2363,10 +2361,9 @@
           </a:lstStyle>
           <a:p>
             <a:r>
-              <a:rPr lang="en-US" smtClean="0"/>
+              <a:rPr lang="en-US"/>
               <a:t>Click to edit Master title style</a:t>
             </a:r>
-            <a:endParaRPr lang="en-US"/>
           </a:p>
         </p:txBody>
       </p:sp>
@@ -2490,7 +2487,7 @@
           <a:p>
             <a:pPr lvl="0"/>
             <a:r>
-              <a:rPr lang="en-US" smtClean="0"/>
+              <a:rPr lang="en-US"/>
               <a:t>Click to edit Master text styles</a:t>
             </a:r>
           </a:p>
@@ -2513,7 +2510,7 @@
           <a:p>
             <a:fld id="{5BCAD085-E8A6-8845-BD4E-CB4CCA059FC4}" type="datetimeFigureOut">
               <a:rPr lang="en-US" smtClean="0"/>
-              <a:t>1/27/13</a:t>
+              <a:t>8/20/2026</a:t>
             </a:fld>
             <a:endParaRPr lang="en-US"/>
           </a:p>
@@ -2622,10 +2619,9 @@
           <a:lstStyle/>
           <a:p>
             <a:r>
-              <a:rPr lang="en-US" smtClean="0"/>
+              <a:rPr lang="en-US"/>
               <a:t>Click to edit Master title style</a:t>
             </a:r>
-            <a:endParaRPr lang="en-US"/>
           </a:p>
         </p:txBody>
       </p:sp>
@@ -2656,38 +2652,37 @@
           <a:p>
             <a:pPr lvl="0"/>
             <a:r>
-              <a:rPr lang="en-US" smtClean="0"/>
+              <a:rPr lang="en-US"/>
               <a:t>Click to edit Master text styles</a:t>
             </a:r>
           </a:p>
           <a:p>
             <a:pPr lvl="1"/>
             <a:r>
-              <a:rPr lang="en-US" smtClean="0"/>
+              <a:rPr lang="en-US"/>
               <a:t>Second level</a:t>
             </a:r>
           </a:p>
           <a:p>
             <a:pPr lvl="2"/>
             <a:r>
-              <a:rPr lang="en-US" smtClean="0"/>
+              <a:rPr lang="en-US"/>
               <a:t>Third level</a:t>
             </a:r>
           </a:p>
           <a:p>
             <a:pPr lvl="3"/>
             <a:r>
-              <a:rPr lang="en-US" smtClean="0"/>
+              <a:rPr lang="en-US"/>
               <a:t>Fourth level</a:t>
             </a:r>
           </a:p>
           <a:p>
             <a:pPr lvl="4"/>
             <a:r>
-              <a:rPr lang="en-US" smtClean="0"/>
+              <a:rPr lang="en-US"/>
               <a:t>Fifth level</a:t>
             </a:r>
-            <a:endParaRPr lang="en-US"/>
           </a:p>
         </p:txBody>
       </p:sp>
@@ -2726,7 +2721,7 @@
           <a:p>
             <a:fld id="{5BCAD085-E8A6-8845-BD4E-CB4CCA059FC4}" type="datetimeFigureOut">
               <a:rPr lang="en-US" smtClean="0"/>
-              <a:t>1/27/13</a:t>
+              <a:t>8/20/2026</a:t>
             </a:fld>
             <a:endParaRPr lang="en-US"/>
           </a:p>
@@ -3085,7 +3080,7 @@
 </file>
 
 <file path=ppt/slides/slide1.xml><?xml version="1.0" encoding="utf-8"?>
-<p:sld xmlns:a="http://schemas.openxmlformats.org/drawingml/2006/main" xmlns:p="http://schemas.openxmlformats.org/presentationml/2006/main" xmlns:r="http://schemas.openxmlformats.org/officeDocument/2006/relationships">
+<p:sld xmlns:a="http://schemas.openxmlformats.org/drawingml/2006/main" xmlns:r="http://schemas.openxmlformats.org/officeDocument/2006/relationships" xmlns:p="http://schemas.openxmlformats.org/presentationml/2006/main">
   <p:cSld>
     <p:bg>
       <p:bgPr>
@@ -3101,7 +3096,14 @@
         <p:cNvGrpSpPr/>
         <p:nvPr/>
       </p:nvGrpSpPr>
-      <p:grpSpPr/>
+      <p:grpSpPr>
+        <a:xfrm>
+          <a:off x="0" y="0"/>
+          <a:ext cx="0" cy="0"/>
+          <a:chOff x="0" y="0"/>
+          <a:chExt cx="0" cy="0"/>
+        </a:xfrm>
+      </p:grpSpPr>
       <p:sp>
         <p:nvSpPr>
           <p:cNvPr id="2" name="TextBox 1"/>
@@ -3175,6 +3177,7 @@
           <a:lstStyle/>
           <a:p>
             <a:pPr algn="ctr"/>
+            <a:endParaRPr/>
           </a:p>
         </p:txBody>
       </p:sp>
@@ -3220,7 +3223,7 @@
 </file>
 
 <file path=ppt/slides/slide2.xml><?xml version="1.0" encoding="utf-8"?>
-<p:sld xmlns:a="http://schemas.openxmlformats.org/drawingml/2006/main" xmlns:p="http://schemas.openxmlformats.org/presentationml/2006/main" xmlns:r="http://schemas.openxmlformats.org/officeDocument/2006/relationships">
+<p:sld xmlns:a="http://schemas.openxmlformats.org/drawingml/2006/main" xmlns:r="http://schemas.openxmlformats.org/officeDocument/2006/relationships" xmlns:p="http://schemas.openxmlformats.org/presentationml/2006/main">
   <p:cSld>
     <p:bg>
       <p:bgPr>
@@ -3236,7 +3239,14 @@
         <p:cNvGrpSpPr/>
         <p:nvPr/>
       </p:nvGrpSpPr>
-      <p:grpSpPr/>
+      <p:grpSpPr>
+        <a:xfrm>
+          <a:off x="0" y="0"/>
+          <a:ext cx="0" cy="0"/>
+          <a:chOff x="0" y="0"/>
+          <a:chExt cx="0" cy="0"/>
+        </a:xfrm>
+      </p:grpSpPr>
       <p:sp>
         <p:nvSpPr>
           <p:cNvPr id="2" name="Rectangle 1"/>
@@ -3277,6 +3287,7 @@
           <a:lstStyle/>
           <a:p>
             <a:pPr algn="ctr"/>
+            <a:endParaRPr/>
           </a:p>
         </p:txBody>
       </p:sp>
@@ -3402,6 +3413,7 @@
           <a:lstStyle/>
           <a:p>
             <a:pPr algn="ctr"/>
+            <a:endParaRPr/>
           </a:p>
         </p:txBody>
       </p:sp>
@@ -3445,6 +3457,7 @@
           <a:lstStyle/>
           <a:p>
             <a:pPr algn="ctr"/>
+            <a:endParaRPr/>
           </a:p>
         </p:txBody>
       </p:sp>
@@ -3529,6 +3542,7 @@
           <a:lstStyle/>
           <a:p>
             <a:pPr algn="ctr"/>
+            <a:endParaRPr/>
           </a:p>
         </p:txBody>
       </p:sp>
@@ -3654,6 +3668,7 @@
           <a:lstStyle/>
           <a:p>
             <a:pPr algn="ctr"/>
+            <a:endParaRPr/>
           </a:p>
         </p:txBody>
       </p:sp>
@@ -3697,6 +3712,7 @@
           <a:lstStyle/>
           <a:p>
             <a:pPr algn="ctr"/>
+            <a:endParaRPr/>
           </a:p>
         </p:txBody>
       </p:sp>
@@ -3824,6 +3840,7 @@
           <a:lstStyle/>
           <a:p>
             <a:pPr algn="ctr"/>
+            <a:endParaRPr/>
           </a:p>
         </p:txBody>
       </p:sp>
@@ -3867,6 +3884,7 @@
           <a:lstStyle/>
           <a:p>
             <a:pPr algn="ctr"/>
+            <a:endParaRPr/>
           </a:p>
         </p:txBody>
       </p:sp>
@@ -3963,7 +3981,7 @@
 </file>
 
 <file path=ppt/slides/slide3.xml><?xml version="1.0" encoding="utf-8"?>
-<p:sld xmlns:a="http://schemas.openxmlformats.org/drawingml/2006/main" xmlns:p="http://schemas.openxmlformats.org/presentationml/2006/main" xmlns:r="http://schemas.openxmlformats.org/officeDocument/2006/relationships">
+<p:sld xmlns:a="http://schemas.openxmlformats.org/drawingml/2006/main" xmlns:r="http://schemas.openxmlformats.org/officeDocument/2006/relationships" xmlns:p="http://schemas.openxmlformats.org/presentationml/2006/main">
   <p:cSld>
     <p:bg>
       <p:bgPr>
@@ -3979,7 +3997,14 @@
         <p:cNvGrpSpPr/>
         <p:nvPr/>
       </p:nvGrpSpPr>
-      <p:grpSpPr/>
+      <p:grpSpPr>
+        <a:xfrm>
+          <a:off x="0" y="0"/>
+          <a:ext cx="0" cy="0"/>
+          <a:chOff x="0" y="0"/>
+          <a:chExt cx="0" cy="0"/>
+        </a:xfrm>
+      </p:grpSpPr>
       <p:sp>
         <p:nvSpPr>
           <p:cNvPr id="2" name="Rectangle 1"/>
@@ -4020,6 +4045,7 @@
           <a:lstStyle/>
           <a:p>
             <a:pPr algn="ctr"/>
+            <a:endParaRPr/>
           </a:p>
         </p:txBody>
       </p:sp>
@@ -4032,7 +4058,7 @@
         <p:spPr>
           <a:xfrm>
             <a:off x="640080" y="182880"/>
-            <a:ext cx="7772400" cy="731520"/>
+            <a:ext cx="4601003" cy="369332"/>
           </a:xfrm>
           <a:prstGeom prst="rect">
             <a:avLst/>
@@ -4046,13 +4072,18 @@
           <a:lstStyle/>
           <a:p>
             <a:r>
-              <a:rPr>
+              <a:rPr lang="en-US">
                 <a:solidFill>
                   <a:srgbClr val="FFFFFF"/>
                 </a:solidFill>
               </a:rPr>
-              <a:t>2. R-Learner &amp; Phân phối CATE</a:t>
-            </a:r>
+              <a:t>2. Simplified R-Learner-style và phân phối CATE</a:t>
+            </a:r>
+            <a:endParaRPr>
+              <a:solidFill>
+                <a:srgbClr val="FFFFFF"/>
+              </a:solidFill>
+            </a:endParaRPr>
           </a:p>
         </p:txBody>
       </p:sp>
@@ -4129,6 +4160,7 @@
           <a:lstStyle/>
           <a:p>
             <a:pPr algn="ctr"/>
+            <a:endParaRPr/>
           </a:p>
         </p:txBody>
       </p:sp>
@@ -4172,6 +4204,7 @@
           <a:lstStyle/>
           <a:p>
             <a:pPr algn="ctr"/>
+            <a:endParaRPr/>
           </a:p>
         </p:txBody>
       </p:sp>
@@ -4256,6 +4289,7 @@
           <a:lstStyle/>
           <a:p>
             <a:pPr algn="ctr"/>
+            <a:endParaRPr/>
           </a:p>
         </p:txBody>
       </p:sp>
@@ -4381,6 +4415,7 @@
           <a:lstStyle/>
           <a:p>
             <a:pPr algn="ctr"/>
+            <a:endParaRPr/>
           </a:p>
         </p:txBody>
       </p:sp>
@@ -4424,6 +4459,7 @@
           <a:lstStyle/>
           <a:p>
             <a:pPr algn="ctr"/>
+            <a:endParaRPr/>
           </a:p>
         </p:txBody>
       </p:sp>
@@ -4450,13 +4486,18 @@
           <a:lstStyle/>
           <a:p>
             <a:r>
-              <a:rPr>
+              <a:rPr lang="en-US">
                 <a:solidFill>
                   <a:srgbClr val="FFFFFF"/>
                 </a:solidFill>
               </a:rPr>
-              <a:t>R-Learner (XGBoost-based)</a:t>
-            </a:r>
+              <a:t>Simplified R-Learner-style</a:t>
+            </a:r>
+            <a:endParaRPr>
+              <a:solidFill>
+                <a:srgbClr val="FFFFFF"/>
+              </a:solidFill>
+            </a:endParaRPr>
           </a:p>
         </p:txBody>
       </p:sp>
@@ -4469,7 +4510,7 @@
         <p:spPr>
           <a:xfrm>
             <a:off x="685800" y="1874520"/>
-            <a:ext cx="3749040" cy="1783080"/>
+            <a:ext cx="3749040" cy="1477328"/>
           </a:xfrm>
           <a:prstGeom prst="rect">
             <a:avLst/>
@@ -4483,23 +4524,44 @@
           <a:lstStyle/>
           <a:p>
             <a:r>
-              <a:rPr>
+              <a:rPr lang="vi-VN">
                 <a:solidFill>
                   <a:srgbClr val="FFFFFF"/>
                 </a:solidFill>
               </a:rPr>
-              <a:t>• Residualize outcome và treatment để ước lượng HTE.</a:t>
-            </a:r>
-          </a:p>
-          <a:p>
-            <a:r>
-              <a:rPr>
+              <a:t>• Model 1 học m(X), sau đó residualize outcome và treatment.</a:t>
+            </a:r>
+          </a:p>
+          <a:p>
+            <a:r>
+              <a:rPr lang="vi-VN">
                 <a:solidFill>
                   <a:srgbClr val="FFFFFF"/>
                 </a:solidFill>
               </a:rPr>
-              <a:t>• Train/Validation/Test = 60/20/20; Test giữ riêng cho final evaluation.</a:t>
-            </a:r>
+              <a:t>• Model 2 học </a:t>
+            </a:r>
+            <a:r>
+              <a:rPr lang="el-GR">
+                <a:solidFill>
+                  <a:srgbClr val="FFFFFF"/>
+                </a:solidFill>
+              </a:rPr>
+              <a:t>τ(</a:t>
+            </a:r>
+            <a:r>
+              <a:rPr lang="vi-VN">
+                <a:solidFill>
+                  <a:srgbClr val="FFFFFF"/>
+                </a:solidFill>
+              </a:rPr>
+              <a:t>X); chưa dùng cross-fitting nên không gọi là full DML.</a:t>
+            </a:r>
+            <a:endParaRPr>
+              <a:solidFill>
+                <a:srgbClr val="FFFFFF"/>
+              </a:solidFill>
+            </a:endParaRPr>
           </a:p>
         </p:txBody>
       </p:sp>
@@ -4543,6 +4605,7 @@
           <a:lstStyle/>
           <a:p>
             <a:pPr algn="ctr"/>
+            <a:endParaRPr/>
           </a:p>
         </p:txBody>
       </p:sp>
@@ -4586,6 +4649,7 @@
           <a:lstStyle/>
           <a:p>
             <a:pPr algn="ctr"/>
+            <a:endParaRPr/>
           </a:p>
         </p:txBody>
       </p:sp>
@@ -4639,7 +4703,7 @@
         <p:spPr>
           <a:xfrm>
             <a:off x="685800" y="4251960"/>
-            <a:ext cx="3749040" cy="1783080"/>
+            <a:ext cx="3749040" cy="1200329"/>
           </a:xfrm>
           <a:prstGeom prst="rect">
             <a:avLst/>
@@ -4653,19 +4717,40 @@
           <a:lstStyle/>
           <a:p>
             <a:r>
-              <a:rPr>
+              <a:rPr lang="en-US">
                 <a:solidFill>
                   <a:srgbClr val="FFFFFF"/>
                 </a:solidFill>
               </a:rPr>
-              <a:t>• Phân phối predicted CATE cho thấy response không đồng nhất giữa các user trong synthetic sandbox.</a:t>
-            </a:r>
+              <a:t>• Mean CATE dự báo = 0,955 chuyến/30 ngày.</a:t>
+            </a:r>
+          </a:p>
+          <a:p>
+            <a:r>
+              <a:rPr lang="en-US">
+                <a:solidFill>
+                  <a:srgbClr val="FFFFFF"/>
+                </a:solidFill>
+              </a:rPr>
+              <a:t>• Phân phối rộng cho thấy response khác nhau giữa các khách hàng.</a:t>
+            </a:r>
+            <a:endParaRPr>
+              <a:solidFill>
+                <a:srgbClr val="FFFFFF"/>
+              </a:solidFill>
+            </a:endParaRPr>
           </a:p>
         </p:txBody>
       </p:sp>
       <p:pic>
         <p:nvPicPr>
-          <p:cNvPr id="19" name="Picture 18" descr="week7_uplift_modeling_0.png"/>
+          <p:cNvPr id="21" name="CATE Distribution - Current Snapshot" descr="Biểu đồ nguồn: notebook và report trong repository">
+            <a:extLst>
+              <a:ext uri="{FF2B5EF4-FFF2-40B4-BE49-F238E27FC236}">
+                <a16:creationId xmlns:a16="http://schemas.microsoft.com/office/drawing/2014/main" id="{E24C2B42-7D49-4622-95DA-2C1DE5A6A5C2}"/>
+              </a:ext>
+            </a:extLst>
+          </p:cNvPr>
           <p:cNvPicPr>
             <a:picLocks noChangeAspect="1"/>
           </p:cNvPicPr>
@@ -4679,8 +4764,8 @@
         </p:blipFill>
         <p:spPr>
           <a:xfrm>
-            <a:off x="4572000" y="2286000"/>
-            <a:ext cx="4206240" cy="2347210"/>
+            <a:off x="4572000" y="2291599"/>
+            <a:ext cx="4206240" cy="2336012"/>
           </a:xfrm>
           <a:prstGeom prst="rect">
             <a:avLst/>
@@ -4696,7 +4781,7 @@
 </file>
 
 <file path=ppt/slides/slide4.xml><?xml version="1.0" encoding="utf-8"?>
-<p:sld xmlns:a="http://schemas.openxmlformats.org/drawingml/2006/main" xmlns:p="http://schemas.openxmlformats.org/presentationml/2006/main" xmlns:r="http://schemas.openxmlformats.org/officeDocument/2006/relationships">
+<p:sld xmlns:a="http://schemas.openxmlformats.org/drawingml/2006/main" xmlns:r="http://schemas.openxmlformats.org/officeDocument/2006/relationships" xmlns:p="http://schemas.openxmlformats.org/presentationml/2006/main">
   <p:cSld>
     <p:bg>
       <p:bgPr>
@@ -4712,7 +4797,14 @@
         <p:cNvGrpSpPr/>
         <p:nvPr/>
       </p:nvGrpSpPr>
-      <p:grpSpPr/>
+      <p:grpSpPr>
+        <a:xfrm>
+          <a:off x="0" y="0"/>
+          <a:ext cx="0" cy="0"/>
+          <a:chOff x="0" y="0"/>
+          <a:chExt cx="0" cy="0"/>
+        </a:xfrm>
+      </p:grpSpPr>
       <p:sp>
         <p:nvSpPr>
           <p:cNvPr id="2" name="Rectangle 1"/>
@@ -4753,6 +4845,7 @@
           <a:lstStyle/>
           <a:p>
             <a:pPr algn="ctr"/>
+            <a:endParaRPr/>
           </a:p>
         </p:txBody>
       </p:sp>
@@ -4765,7 +4858,7 @@
         <p:spPr>
           <a:xfrm>
             <a:off x="640080" y="182880"/>
-            <a:ext cx="7772400" cy="731520"/>
+            <a:ext cx="8207696" cy="492443"/>
           </a:xfrm>
           <a:prstGeom prst="rect">
             <a:avLst/>
@@ -4787,13 +4880,18 @@
               </a:defRPr>
             </a:pPr>
             <a:r>
-              <a:rPr>
+              <a:rPr lang="en-US">
                 <a:solidFill>
                   <a:srgbClr val="FFFFFF"/>
                 </a:solidFill>
               </a:rPr>
-              <a:t>3. Đánh giá Mô hình (Qini Curve)</a:t>
-            </a:r>
+              <a:t>3. Qini: Mô hình xếp hạng khách hàng tốt đến đâu?</a:t>
+            </a:r>
+            <a:endParaRPr>
+              <a:solidFill>
+                <a:srgbClr val="FFFFFF"/>
+              </a:solidFill>
+            </a:endParaRPr>
           </a:p>
         </p:txBody>
       </p:sp>
@@ -4806,7 +4904,7 @@
         <p:spPr>
           <a:xfrm>
             <a:off x="640080" y="731520"/>
-            <a:ext cx="7772400" cy="365760"/>
+            <a:ext cx="5328895" cy="369332"/>
           </a:xfrm>
           <a:prstGeom prst="rect">
             <a:avLst/>
@@ -4820,13 +4918,18 @@
           <a:lstStyle/>
           <a:p>
             <a:r>
-              <a:rPr>
+              <a:rPr lang="en-US">
                 <a:solidFill>
                   <a:srgbClr val="FFFFFF"/>
                 </a:solidFill>
               </a:rPr>
-              <a:t>Positive ranking signal so với Random</a:t>
-            </a:r>
+              <a:t>Ranking tốt hơn ngẫu nhiên trên cùng held-out test set</a:t>
+            </a:r>
+            <a:endParaRPr>
+              <a:solidFill>
+                <a:srgbClr val="FFFFFF"/>
+              </a:solidFill>
+            </a:endParaRPr>
           </a:p>
         </p:txBody>
       </p:sp>
@@ -4870,6 +4973,7 @@
           <a:lstStyle/>
           <a:p>
             <a:pPr algn="ctr"/>
+            <a:endParaRPr/>
           </a:p>
         </p:txBody>
       </p:sp>
@@ -4913,6 +5017,7 @@
           <a:lstStyle/>
           <a:p>
             <a:pPr algn="ctr"/>
+            <a:endParaRPr/>
           </a:p>
         </p:txBody>
       </p:sp>
@@ -4997,6 +5102,7 @@
           <a:lstStyle/>
           <a:p>
             <a:pPr algn="ctr"/>
+            <a:endParaRPr/>
           </a:p>
         </p:txBody>
       </p:sp>
@@ -5122,6 +5228,7 @@
           <a:lstStyle/>
           <a:p>
             <a:pPr algn="ctr"/>
+            <a:endParaRPr/>
           </a:p>
         </p:txBody>
       </p:sp>
@@ -5165,6 +5272,7 @@
           <a:lstStyle/>
           <a:p>
             <a:pPr algn="ctr"/>
+            <a:endParaRPr/>
           </a:p>
         </p:txBody>
       </p:sp>
@@ -5218,7 +5326,7 @@
         <p:spPr>
           <a:xfrm>
             <a:off x="685800" y="1874520"/>
-            <a:ext cx="3749040" cy="1783080"/>
+            <a:ext cx="3749040" cy="1200329"/>
           </a:xfrm>
           <a:prstGeom prst="rect">
             <a:avLst/>
@@ -5232,23 +5340,28 @@
           <a:lstStyle/>
           <a:p>
             <a:r>
-              <a:rPr>
+              <a:rPr lang="vi-VN">
                 <a:solidFill>
                   <a:srgbClr val="FFFFFF"/>
                 </a:solidFill>
               </a:rPr>
-              <a:t>• Đo khả năng xếp hạng user theo incremental response.</a:t>
-            </a:r>
-          </a:p>
-          <a:p>
-            <a:r>
-              <a:rPr>
+              <a:t>• Qini đo chất lượng xếp hạng incremental response.</a:t>
+            </a:r>
+          </a:p>
+          <a:p>
+            <a:r>
+              <a:rPr lang="vi-VN">
                 <a:solidFill>
                   <a:srgbClr val="FFFFFF"/>
                 </a:solidFill>
               </a:rPr>
-              <a:t>• Đường model nằm trên random baseline cho thấy ranking signal trong synthetic test set.</a:t>
-            </a:r>
+              <a:t>• Snapshot đã khóa: Qini Coef = 0,188 trên 4.000 khách hàng.</a:t>
+            </a:r>
+            <a:endParaRPr>
+              <a:solidFill>
+                <a:srgbClr val="FFFFFF"/>
+              </a:solidFill>
+            </a:endParaRPr>
           </a:p>
         </p:txBody>
       </p:sp>
@@ -5292,6 +5405,7 @@
           <a:lstStyle/>
           <a:p>
             <a:pPr algn="ctr"/>
+            <a:endParaRPr/>
           </a:p>
         </p:txBody>
       </p:sp>
@@ -5335,6 +5449,7 @@
           <a:lstStyle/>
           <a:p>
             <a:pPr algn="ctr"/>
+            <a:endParaRPr/>
           </a:p>
         </p:txBody>
       </p:sp>
@@ -5388,7 +5503,7 @@
         <p:spPr>
           <a:xfrm>
             <a:off x="685800" y="4251960"/>
-            <a:ext cx="3749040" cy="1783080"/>
+            <a:ext cx="3749040" cy="1477328"/>
           </a:xfrm>
           <a:prstGeom prst="rect">
             <a:avLst/>
@@ -5402,29 +5517,40 @@
           <a:lstStyle/>
           <a:p>
             <a:r>
-              <a:rPr>
+              <a:rPr lang="vi-VN">
                 <a:solidFill>
                   <a:srgbClr val="FFFFFF"/>
                 </a:solidFill>
               </a:rPr>
-              <a:t>• R-Learner cho thấy positive ranking signal trên held-out synthetic test set.</a:t>
-            </a:r>
-          </a:p>
-          <a:p>
-            <a:r>
-              <a:rPr>
+              <a:t>• Champion có tín hiệu ranking hữu ích so với random.</a:t>
+            </a:r>
+          </a:p>
+          <a:p>
+            <a:r>
+              <a:rPr lang="vi-VN">
                 <a:solidFill>
                   <a:srgbClr val="FFFFFF"/>
                 </a:solidFill>
               </a:rPr>
-              <a:t>• CATE level calibration vẫn imperfect và cần theo dõi.</a:t>
-            </a:r>
+              <a:t>• Scale CATE chưa hiệu chỉnh hoàn hảo; cần đọc cùng calibration và policy value.</a:t>
+            </a:r>
+            <a:endParaRPr>
+              <a:solidFill>
+                <a:srgbClr val="FFFFFF"/>
+              </a:solidFill>
+            </a:endParaRPr>
           </a:p>
         </p:txBody>
       </p:sp>
       <p:pic>
         <p:nvPicPr>
-          <p:cNvPr id="19" name="Picture 18" descr="week7_uplift_modeling_2.png"/>
+          <p:cNvPr id="21" name="Qini Curve - Frozen Champion Snapshot" descr="Biểu đồ nguồn: notebook và report trong repository">
+            <a:extLst>
+              <a:ext uri="{FF2B5EF4-FFF2-40B4-BE49-F238E27FC236}">
+                <a16:creationId xmlns:a16="http://schemas.microsoft.com/office/drawing/2014/main" id="{34DEA4B9-8EE6-E380-105A-738A9703C09A}"/>
+              </a:ext>
+            </a:extLst>
+          </p:cNvPr>
           <p:cNvPicPr>
             <a:picLocks noChangeAspect="1"/>
           </p:cNvPicPr>
@@ -5438,8 +5564,8 @@
         </p:blipFill>
         <p:spPr>
           <a:xfrm>
-            <a:off x="4572000" y="2286000"/>
-            <a:ext cx="4206240" cy="2742767"/>
+            <a:off x="4572000" y="2488721"/>
+            <a:ext cx="4206240" cy="2337326"/>
           </a:xfrm>
           <a:prstGeom prst="rect">
             <a:avLst/>
@@ -5455,7 +5581,7 @@
 </file>
 
 <file path=ppt/slides/slide5.xml><?xml version="1.0" encoding="utf-8"?>
-<p:sld xmlns:a="http://schemas.openxmlformats.org/drawingml/2006/main" xmlns:p="http://schemas.openxmlformats.org/presentationml/2006/main" xmlns:r="http://schemas.openxmlformats.org/officeDocument/2006/relationships">
+<p:sld xmlns:a="http://schemas.openxmlformats.org/drawingml/2006/main" xmlns:r="http://schemas.openxmlformats.org/officeDocument/2006/relationships" xmlns:p="http://schemas.openxmlformats.org/presentationml/2006/main">
   <p:cSld>
     <p:bg>
       <p:bgPr>
@@ -5471,7 +5597,14 @@
         <p:cNvGrpSpPr/>
         <p:nvPr/>
       </p:nvGrpSpPr>
-      <p:grpSpPr/>
+      <p:grpSpPr>
+        <a:xfrm>
+          <a:off x="0" y="0"/>
+          <a:ext cx="0" cy="0"/>
+          <a:chOff x="0" y="0"/>
+          <a:chExt cx="0" cy="0"/>
+        </a:xfrm>
+      </p:grpSpPr>
       <p:sp>
         <p:nvSpPr>
           <p:cNvPr id="2" name="Rectangle 1"/>
@@ -5512,6 +5645,7 @@
           <a:lstStyle/>
           <a:p>
             <a:pPr algn="ctr"/>
+            <a:endParaRPr/>
           </a:p>
         </p:txBody>
       </p:sp>
@@ -5524,7 +5658,7 @@
         <p:spPr>
           <a:xfrm>
             <a:off x="640080" y="182880"/>
-            <a:ext cx="7772400" cy="731520"/>
+            <a:ext cx="3136371" cy="369332"/>
           </a:xfrm>
           <a:prstGeom prst="rect">
             <a:avLst/>
@@ -5538,13 +5672,18 @@
           <a:lstStyle/>
           <a:p>
             <a:r>
-              <a:rPr>
+              <a:rPr lang="en-US">
                 <a:solidFill>
                   <a:srgbClr val="FFFFFF"/>
                 </a:solidFill>
               </a:rPr>
-              <a:t>4. Từ Uplift sang Profit-aware Targeting</a:t>
-            </a:r>
+              <a:t>4. Từ CATE sang Profit Targeting</a:t>
+            </a:r>
+            <a:endParaRPr>
+              <a:solidFill>
+                <a:srgbClr val="FFFFFF"/>
+              </a:solidFill>
+            </a:endParaRPr>
           </a:p>
         </p:txBody>
       </p:sp>
@@ -5557,7 +5696,7 @@
         <p:spPr>
           <a:xfrm>
             <a:off x="640080" y="731520"/>
-            <a:ext cx="7772400" cy="365760"/>
+            <a:ext cx="4617098" cy="369332"/>
           </a:xfrm>
           <a:prstGeom prst="rect">
             <a:avLst/>
@@ -5571,13 +5710,18 @@
           <a:lstStyle/>
           <a:p>
             <a:r>
-              <a:rPr>
+              <a:rPr lang="en-US">
                 <a:solidFill>
                   <a:srgbClr val="FFFFFF"/>
                 </a:solidFill>
               </a:rPr>
-              <a:t>Decision Layer: Expected Value &gt; 0</a:t>
-            </a:r>
+              <a:t>Quy tắc quyết định: chỉ phát voucher khi EV &gt; 0</a:t>
+            </a:r>
+            <a:endParaRPr>
+              <a:solidFill>
+                <a:srgbClr val="FFFFFF"/>
+              </a:solidFill>
+            </a:endParaRPr>
           </a:p>
         </p:txBody>
       </p:sp>
@@ -5621,6 +5765,7 @@
           <a:lstStyle/>
           <a:p>
             <a:pPr algn="ctr"/>
+            <a:endParaRPr/>
           </a:p>
         </p:txBody>
       </p:sp>
@@ -5664,6 +5809,7 @@
           <a:lstStyle/>
           <a:p>
             <a:pPr algn="ctr"/>
+            <a:endParaRPr/>
           </a:p>
         </p:txBody>
       </p:sp>
@@ -5748,6 +5894,7 @@
           <a:lstStyle/>
           <a:p>
             <a:pPr algn="ctr"/>
+            <a:endParaRPr/>
           </a:p>
         </p:txBody>
       </p:sp>
@@ -5873,6 +6020,7 @@
           <a:lstStyle/>
           <a:p>
             <a:pPr algn="ctr"/>
+            <a:endParaRPr/>
           </a:p>
         </p:txBody>
       </p:sp>
@@ -5916,6 +6064,7 @@
           <a:lstStyle/>
           <a:p>
             <a:pPr algn="ctr"/>
+            <a:endParaRPr/>
           </a:p>
         </p:txBody>
       </p:sp>
@@ -5969,7 +6118,7 @@
         <p:spPr>
           <a:xfrm>
             <a:off x="685800" y="1874520"/>
-            <a:ext cx="3749040" cy="1783080"/>
+            <a:ext cx="3749040" cy="1200329"/>
           </a:xfrm>
           <a:prstGeom prst="rect">
             <a:avLst/>
@@ -5983,23 +6132,28 @@
           <a:lstStyle/>
           <a:p>
             <a:r>
-              <a:rPr>
+              <a:rPr lang="vi-VN">
                 <a:solidFill>
                   <a:srgbClr val="FFFFFF"/>
                 </a:solidFill>
               </a:rPr>
-              <a:t>• Không chỉ tối ưu CATE mà tính cả incremental contribution và expected burn.</a:t>
-            </a:r>
-          </a:p>
-          <a:p>
-            <a:r>
-              <a:rPr>
+              <a:t>• EV = incremental margin - expected voucher burn.</a:t>
+            </a:r>
+          </a:p>
+          <a:p>
+            <a:r>
+              <a:rPr lang="vi-VN">
                 <a:solidFill>
                   <a:srgbClr val="FFFFFF"/>
                 </a:solidFill>
               </a:rPr>
-              <a:t>• Target user khi Expected Incremental Profit &gt; 0.</a:t>
-            </a:r>
+              <a:t>• CATE cao chưa chắc có lời; target chỉ khi EV &gt; 0.</a:t>
+            </a:r>
+            <a:endParaRPr>
+              <a:solidFill>
+                <a:srgbClr val="FFFFFF"/>
+              </a:solidFill>
+            </a:endParaRPr>
           </a:p>
         </p:txBody>
       </p:sp>
@@ -6043,6 +6197,7 @@
           <a:lstStyle/>
           <a:p>
             <a:pPr algn="ctr"/>
+            <a:endParaRPr/>
           </a:p>
         </p:txBody>
       </p:sp>
@@ -6086,6 +6241,7 @@
           <a:lstStyle/>
           <a:p>
             <a:pPr algn="ctr"/>
+            <a:endParaRPr/>
           </a:p>
         </p:txBody>
       </p:sp>
@@ -6139,7 +6295,7 @@
         <p:spPr>
           <a:xfrm>
             <a:off x="685800" y="4251960"/>
-            <a:ext cx="3749040" cy="1783080"/>
+            <a:ext cx="3749040" cy="1200329"/>
           </a:xfrm>
           <a:prstGeom prst="rect">
             <a:avLst/>
@@ -6153,29 +6309,40 @@
           <a:lstStyle/>
           <a:p>
             <a:r>
-              <a:rPr>
+              <a:rPr lang="en-US">
                 <a:solidFill>
                   <a:srgbClr val="FFFFFF"/>
                 </a:solidFill>
               </a:rPr>
-              <a:t>• Profit Targeting chọn 888/4,000 users (22.2%).</a:t>
-            </a:r>
-          </a:p>
-          <a:p>
-            <a:r>
-              <a:rPr>
+              <a:t>• Chọn 888/4.000 khách hàng (22,2%).</a:t>
+            </a:r>
+          </a:p>
+          <a:p>
+            <a:r>
+              <a:rPr lang="en-US">
                 <a:solidFill>
                   <a:srgbClr val="FFFFFF"/>
                 </a:solidFill>
               </a:rPr>
-              <a:t>• Predicted Profit ≈ $7.9k; Synthetic Benchmark ≈ $7.1k.</a:t>
-            </a:r>
+              <a:t>• Predicted profit: $7,939; synthetic benchmark: $7,060.</a:t>
+            </a:r>
+            <a:endParaRPr>
+              <a:solidFill>
+                <a:srgbClr val="FFFFFF"/>
+              </a:solidFill>
+            </a:endParaRPr>
           </a:p>
         </p:txBody>
       </p:sp>
       <p:pic>
         <p:nvPicPr>
-          <p:cNvPr id="19" name="Picture 18" descr="week7_uplift_modeling_1.png"/>
+          <p:cNvPr id="21" name="Profit Targeting Share - Current Snapshot" descr="Biểu đồ nguồn: notebook và report trong repository">
+            <a:extLst>
+              <a:ext uri="{FF2B5EF4-FFF2-40B4-BE49-F238E27FC236}">
+                <a16:creationId xmlns:a16="http://schemas.microsoft.com/office/drawing/2014/main" id="{12C9C853-50F1-4477-5213-7C15EACE8BA1}"/>
+              </a:ext>
+            </a:extLst>
+          </p:cNvPr>
           <p:cNvPicPr>
             <a:picLocks noChangeAspect="1"/>
           </p:cNvPicPr>
@@ -6189,8 +6356,8 @@
         </p:blipFill>
         <p:spPr>
           <a:xfrm>
-            <a:off x="4572000" y="2286000"/>
-            <a:ext cx="4206240" cy="3559126"/>
+            <a:off x="5063340" y="2286000"/>
+            <a:ext cx="3223561" cy="3559126"/>
           </a:xfrm>
           <a:prstGeom prst="rect">
             <a:avLst/>
@@ -6206,7 +6373,7 @@
 </file>
 
 <file path=ppt/slides/slide6.xml><?xml version="1.0" encoding="utf-8"?>
-<p:sld xmlns:a="http://schemas.openxmlformats.org/drawingml/2006/main" xmlns:p="http://schemas.openxmlformats.org/presentationml/2006/main" xmlns:r="http://schemas.openxmlformats.org/officeDocument/2006/relationships">
+<p:sld xmlns:a="http://schemas.openxmlformats.org/drawingml/2006/main" xmlns:r="http://schemas.openxmlformats.org/officeDocument/2006/relationships" xmlns:p="http://schemas.openxmlformats.org/presentationml/2006/main">
   <p:cSld>
     <p:bg>
       <p:bgPr>
@@ -6222,7 +6389,14 @@
         <p:cNvGrpSpPr/>
         <p:nvPr/>
       </p:nvGrpSpPr>
-      <p:grpSpPr/>
+      <p:grpSpPr>
+        <a:xfrm>
+          <a:off x="0" y="0"/>
+          <a:ext cx="0" cy="0"/>
+          <a:chOff x="0" y="0"/>
+          <a:chExt cx="0" cy="0"/>
+        </a:xfrm>
+      </p:grpSpPr>
       <p:sp>
         <p:nvSpPr>
           <p:cNvPr id="2" name="Rectangle 1"/>
@@ -6263,6 +6437,7 @@
           <a:lstStyle/>
           <a:p>
             <a:pPr algn="ctr"/>
+            <a:endParaRPr/>
           </a:p>
         </p:txBody>
       </p:sp>
@@ -6275,7 +6450,7 @@
         <p:spPr>
           <a:xfrm>
             <a:off x="640080" y="182880"/>
-            <a:ext cx="7772400" cy="731520"/>
+            <a:ext cx="4414863" cy="369332"/>
           </a:xfrm>
           <a:prstGeom prst="rect">
             <a:avLst/>
@@ -6289,13 +6464,18 @@
           <a:lstStyle/>
           <a:p>
             <a:r>
-              <a:rPr>
+              <a:rPr lang="en-US">
                 <a:solidFill>
                   <a:srgbClr val="FFFFFF"/>
                 </a:solidFill>
               </a:rPr>
-              <a:t>5. Profit-aware Decision Rule</a:t>
-            </a:r>
+              <a:t>5. Công thức quyết định theo Expected Value</a:t>
+            </a:r>
+            <a:endParaRPr>
+              <a:solidFill>
+                <a:srgbClr val="FFFFFF"/>
+              </a:solidFill>
+            </a:endParaRPr>
           </a:p>
         </p:txBody>
       </p:sp>
@@ -6308,7 +6488,7 @@
         <p:spPr>
           <a:xfrm>
             <a:off x="640080" y="731520"/>
-            <a:ext cx="7772400" cy="365760"/>
+            <a:ext cx="6582571" cy="369332"/>
           </a:xfrm>
           <a:prstGeom prst="rect">
             <a:avLst/>
@@ -6322,13 +6502,18 @@
           <a:lstStyle/>
           <a:p>
             <a:r>
-              <a:rPr>
+              <a:rPr lang="en-US">
                 <a:solidFill>
                   <a:srgbClr val="FFFFFF"/>
                 </a:solidFill>
               </a:rPr>
-              <a:t>High CATE không đồng nghĩa High Profit</a:t>
-            </a:r>
+              <a:t>Giả định sandbox: voucher 15% không cap, contribution margin 70%</a:t>
+            </a:r>
+            <a:endParaRPr>
+              <a:solidFill>
+                <a:srgbClr val="FFFFFF"/>
+              </a:solidFill>
+            </a:endParaRPr>
           </a:p>
         </p:txBody>
       </p:sp>
@@ -6372,6 +6557,7 @@
           <a:lstStyle/>
           <a:p>
             <a:pPr algn="ctr"/>
+            <a:endParaRPr/>
           </a:p>
         </p:txBody>
       </p:sp>
@@ -6415,6 +6601,7 @@
           <a:lstStyle/>
           <a:p>
             <a:pPr algn="ctr"/>
+            <a:endParaRPr/>
           </a:p>
         </p:txBody>
       </p:sp>
@@ -6499,6 +6686,7 @@
           <a:lstStyle/>
           <a:p>
             <a:pPr algn="ctr"/>
+            <a:endParaRPr/>
           </a:p>
         </p:txBody>
       </p:sp>
@@ -6624,6 +6812,7 @@
           <a:lstStyle/>
           <a:p>
             <a:pPr algn="ctr"/>
+            <a:endParaRPr/>
           </a:p>
         </p:txBody>
       </p:sp>
@@ -6667,6 +6856,7 @@
           <a:lstStyle/>
           <a:p>
             <a:pPr algn="ctr"/>
+            <a:endParaRPr/>
           </a:p>
         </p:txBody>
       </p:sp>
@@ -6712,7 +6902,7 @@
         <p:spPr>
           <a:xfrm>
             <a:off x="685800" y="2286000"/>
-            <a:ext cx="3931920" cy="3383280"/>
+            <a:ext cx="3931920" cy="1200329"/>
           </a:xfrm>
           <a:prstGeom prst="rect">
             <a:avLst/>
@@ -6726,23 +6916,28 @@
           <a:lstStyle/>
           <a:p>
             <a:r>
-              <a:rPr>
+              <a:rPr lang="en-US">
                 <a:solidFill>
                   <a:srgbClr val="FFFFFF"/>
                 </a:solidFill>
               </a:rPr>
-              <a:t>• EV_i = Predicted CATE_i × Margin per Ride_i − Expected Burn_i.</a:t>
-            </a:r>
-          </a:p>
-          <a:p>
-            <a:r>
-              <a:rPr>
+              <a:t>• EV_i = CATE_i x margin_per_ride_i - Yhat_i(1) x voucher_cost_per_ride_i.</a:t>
+            </a:r>
+          </a:p>
+          <a:p>
+            <a:r>
+              <a:rPr lang="en-US">
                 <a:solidFill>
                   <a:srgbClr val="FFFFFF"/>
                 </a:solidFill>
               </a:rPr>
-              <a:t>• Target khi EV_i &gt; 0 dưới economics assumptions hiện tại.</a:t>
-            </a:r>
+              <a:t>• Chỉ phát khi EV_i &gt; 0 theo assumptions hiện tại.</a:t>
+            </a:r>
+            <a:endParaRPr>
+              <a:solidFill>
+                <a:srgbClr val="FFFFFF"/>
+              </a:solidFill>
+            </a:endParaRPr>
           </a:p>
         </p:txBody>
       </p:sp>
@@ -6786,6 +6981,7 @@
           <a:lstStyle/>
           <a:p>
             <a:pPr algn="ctr"/>
+            <a:endParaRPr/>
           </a:p>
         </p:txBody>
       </p:sp>
@@ -6829,6 +7025,7 @@
           <a:lstStyle/>
           <a:p>
             <a:pPr algn="ctr"/>
+            <a:endParaRPr/>
           </a:p>
         </p:txBody>
       </p:sp>
@@ -6874,7 +7071,7 @@
         <p:spPr>
           <a:xfrm>
             <a:off x="4892040" y="2286000"/>
-            <a:ext cx="3931920" cy="3383280"/>
+            <a:ext cx="3931920" cy="1200329"/>
           </a:xfrm>
           <a:prstGeom prst="rect">
             <a:avLst/>
@@ -6888,23 +7085,28 @@
           <a:lstStyle/>
           <a:p>
             <a:r>
-              <a:rPr>
+              <a:rPr lang="en-US">
                 <a:solidFill>
                   <a:srgbClr val="FFFFFF"/>
                 </a:solidFill>
               </a:rPr>
-              <a:t>• User có uplift cao vẫn có thể không profitable nếu voucher cost lớn.</a:t>
-            </a:r>
-          </a:p>
-          <a:p>
-            <a:r>
-              <a:rPr>
+              <a:t>• Uplift cao vẫn có thể lỗ nếu baseline rides và promotion burn lớn.</a:t>
+            </a:r>
+          </a:p>
+          <a:p>
+            <a:r>
+              <a:rPr lang="en-US">
                 <a:solidFill>
                   <a:srgbClr val="FFFFFF"/>
                 </a:solidFill>
               </a:rPr>
-              <a:t>• Policy layer cần tối ưu economics, không chỉ response.</a:t>
-            </a:r>
+              <a:t>• Budget policy dùng greedy heuristic, không phải exact knapsack.</a:t>
+            </a:r>
+            <a:endParaRPr>
+              <a:solidFill>
+                <a:srgbClr val="FFFFFF"/>
+              </a:solidFill>
+            </a:endParaRPr>
           </a:p>
         </p:txBody>
       </p:sp>
@@ -6917,7 +7119,7 @@
 </file>
 
 <file path=ppt/slides/slide7.xml><?xml version="1.0" encoding="utf-8"?>
-<p:sld xmlns:a="http://schemas.openxmlformats.org/drawingml/2006/main" xmlns:p="http://schemas.openxmlformats.org/presentationml/2006/main" xmlns:r="http://schemas.openxmlformats.org/officeDocument/2006/relationships">
+<p:sld xmlns:a="http://schemas.openxmlformats.org/drawingml/2006/main" xmlns:r="http://schemas.openxmlformats.org/officeDocument/2006/relationships" xmlns:p="http://schemas.openxmlformats.org/presentationml/2006/main">
   <p:cSld>
     <p:bg>
       <p:bgPr>
@@ -6933,7 +7135,14 @@
         <p:cNvGrpSpPr/>
         <p:nvPr/>
       </p:nvGrpSpPr>
-      <p:grpSpPr/>
+      <p:grpSpPr>
+        <a:xfrm>
+          <a:off x="0" y="0"/>
+          <a:ext cx="0" cy="0"/>
+          <a:chOff x="0" y="0"/>
+          <a:chExt cx="0" cy="0"/>
+        </a:xfrm>
+      </p:grpSpPr>
       <p:sp>
         <p:nvSpPr>
           <p:cNvPr id="2" name="Rectangle 1"/>
@@ -6974,6 +7183,7 @@
           <a:lstStyle/>
           <a:p>
             <a:pPr algn="ctr"/>
+            <a:endParaRPr/>
           </a:p>
         </p:txBody>
       </p:sp>
@@ -7083,6 +7293,7 @@
           <a:lstStyle/>
           <a:p>
             <a:pPr algn="ctr"/>
+            <a:endParaRPr/>
           </a:p>
         </p:txBody>
       </p:sp>
@@ -7126,6 +7337,7 @@
           <a:lstStyle/>
           <a:p>
             <a:pPr algn="ctr"/>
+            <a:endParaRPr/>
           </a:p>
         </p:txBody>
       </p:sp>
@@ -7210,6 +7422,7 @@
           <a:lstStyle/>
           <a:p>
             <a:pPr algn="ctr"/>
+            <a:endParaRPr/>
           </a:p>
         </p:txBody>
       </p:sp>
@@ -7335,6 +7548,7 @@
           <a:lstStyle/>
           <a:p>
             <a:pPr algn="ctr"/>
+            <a:endParaRPr/>
           </a:p>
         </p:txBody>
       </p:sp>
@@ -7378,6 +7592,7 @@
           <a:lstStyle/>
           <a:p>
             <a:pPr algn="ctr"/>
+            <a:endParaRPr/>
           </a:p>
         </p:txBody>
       </p:sp>
@@ -7487,6 +7702,7 @@
           <a:lstStyle/>
           <a:p>
             <a:pPr algn="ctr"/>
+            <a:endParaRPr/>
           </a:p>
         </p:txBody>
       </p:sp>
@@ -7530,6 +7746,7 @@
           <a:lstStyle/>
           <a:p>
             <a:pPr algn="ctr"/>
+            <a:endParaRPr/>
           </a:p>
         </p:txBody>
       </p:sp>
@@ -7542,7 +7759,7 @@
         <p:spPr>
           <a:xfrm>
             <a:off x="3550920" y="1691640"/>
-            <a:ext cx="2590800" cy="502920"/>
+            <a:ext cx="2590800" cy="369332"/>
           </a:xfrm>
           <a:prstGeom prst="rect">
             <a:avLst/>
@@ -7556,13 +7773,18 @@
           <a:lstStyle/>
           <a:p>
             <a:r>
-              <a:rPr>
+              <a:rPr lang="en-US">
                 <a:solidFill>
                   <a:srgbClr val="FFFFFF"/>
                 </a:solidFill>
               </a:rPr>
-              <a:t>2. R-Learner Ranking</a:t>
-            </a:r>
+              <a:t>2. Residual model ranking</a:t>
+            </a:r>
+            <a:endParaRPr>
+              <a:solidFill>
+                <a:srgbClr val="FFFFFF"/>
+              </a:solidFill>
+            </a:endParaRPr>
           </a:p>
         </p:txBody>
       </p:sp>
@@ -7575,7 +7797,7 @@
         <p:spPr>
           <a:xfrm>
             <a:off x="3550920" y="2286000"/>
-            <a:ext cx="2590800" cy="3383280"/>
+            <a:ext cx="2590800" cy="1477328"/>
           </a:xfrm>
           <a:prstGeom prst="rect">
             <a:avLst/>
@@ -7589,13 +7811,28 @@
           <a:lstStyle/>
           <a:p>
             <a:r>
-              <a:rPr>
+              <a:rPr lang="en-US">
                 <a:solidFill>
                   <a:srgbClr val="FFFFFF"/>
                 </a:solidFill>
               </a:rPr>
-              <a:t>• Dùng heterogeneous response để hỗ trợ targeting, không chỉ dựa vào behavioral segmentation.</a:t>
-            </a:r>
+              <a:t>• Dùng simplified R-Learner-style để xếp hạng response.</a:t>
+            </a:r>
+          </a:p>
+          <a:p>
+            <a:r>
+              <a:rPr lang="en-US">
+                <a:solidFill>
+                  <a:srgbClr val="FFFFFF"/>
+                </a:solidFill>
+              </a:rPr>
+              <a:t>• Qini Coef = 0,188 trên frozen snapshot.</a:t>
+            </a:r>
+            <a:endParaRPr>
+              <a:solidFill>
+                <a:srgbClr val="FFFFFF"/>
+              </a:solidFill>
+            </a:endParaRPr>
           </a:p>
         </p:txBody>
       </p:sp>
@@ -7639,6 +7876,7 @@
           <a:lstStyle/>
           <a:p>
             <a:pPr algn="ctr"/>
+            <a:endParaRPr/>
           </a:p>
         </p:txBody>
       </p:sp>
@@ -7682,6 +7920,7 @@
           <a:lstStyle/>
           <a:p>
             <a:pPr algn="ctr"/>
+            <a:endParaRPr/>
           </a:p>
         </p:txBody>
       </p:sp>

</xml_diff>